<commit_message>
Fix deck PPTX corruption, add governance bubbles, combine download formats per row
The exec deck PPTX had duplicate effectLst elements on shadowed shapes (empty from
shadow.inherit=False plus a custom shadow), which PowerPoint rejects with a repair
prompt while LibreOffice tolerated it. Rewrote the shadow to reuse the single
effectLst; validated zero duplicates and a clean OOXML round-trip. Redesigned the
governance slide with four dedicated people-side bubbles (committee, AI in mission,
culture, champions) plus a platform strip. Collapsed the download table so each
artifact is one row with formats on one line (PPTX . PDF).

Co-authored-by: Copilot <223556219+Copilot@users.noreply.github.com>
</commit_message>
<xml_diff>
--- a/education playground/assets/copilot licensing and deployment/Copilot-Licensing-Exec-Deck.pptx
+++ b/education playground/assets/copilot licensing and deployment/Copilot-Licensing-Exec-Deck.pptx
@@ -4461,7 +4461,7 @@
                 </a:solidFill>
                 <a:latin typeface="Segoe UI Semibold"/>
               </a:rPr>
-              <a:t>Handle the three dated compliance items</a:t>
+              <a:t>Handle the compliance guardrails</a:t>
             </a:r>
           </a:p>
         </p:txBody>
@@ -4506,7 +4506,7 @@
                 </a:solidFill>
                 <a:latin typeface="Segoe UI"/>
               </a:rPr>
-              <a:t>The July 24 one first.</a:t>
+              <a:t>The OpenAI subprocessor decision first.</a:t>
             </a:r>
           </a:p>
         </p:txBody>
@@ -5067,7 +5067,6 @@
           <a:ln>
             <a:noFill/>
           </a:ln>
-          <a:effectLst/>
           <a:effectLst>
             <a:outerShdw blurRad="90000" dist="38000" dir="5400000" rotWithShape="0">
               <a:srgbClr val="000000">
@@ -5254,7 +5253,6 @@
           <a:ln>
             <a:noFill/>
           </a:ln>
-          <a:effectLst/>
           <a:effectLst>
             <a:outerShdw blurRad="90000" dist="38000" dir="5400000" rotWithShape="0">
               <a:srgbClr val="000000">
@@ -5441,7 +5439,6 @@
           <a:ln>
             <a:noFill/>
           </a:ln>
-          <a:effectLst/>
           <a:effectLst>
             <a:outerShdw blurRad="90000" dist="38000" dir="5400000" rotWithShape="0">
               <a:srgbClr val="000000">
@@ -5871,7 +5868,6 @@
               <a:srgbClr val="DEDEDE"/>
             </a:solidFill>
           </a:ln>
-          <a:effectLst/>
           <a:effectLst>
             <a:outerShdw blurRad="90000" dist="38000" dir="5400000" rotWithShape="0">
               <a:srgbClr val="000000">
@@ -6106,7 +6102,6 @@
               <a:srgbClr val="B11F4B"/>
             </a:solidFill>
           </a:ln>
-          <a:effectLst/>
           <a:effectLst>
             <a:outerShdw blurRad="90000" dist="38000" dir="5400000" rotWithShape="0">
               <a:srgbClr val="000000">
@@ -6341,7 +6336,6 @@
               <a:srgbClr val="DEDEDE"/>
             </a:solidFill>
           </a:ln>
-          <a:effectLst/>
           <a:effectLst>
             <a:outerShdw blurRad="90000" dist="38000" dir="5400000" rotWithShape="0">
               <a:srgbClr val="000000">
@@ -8835,8 +8829,8 @@
         </p:nvSpPr>
         <p:spPr>
           <a:xfrm>
-            <a:off x="640080" y="1600200"/>
-            <a:ext cx="10881360" cy="502920"/>
+            <a:off x="640080" y="1572768"/>
+            <a:ext cx="10881360" cy="365760"/>
           </a:xfrm>
           <a:prstGeom prst="rect">
             <a:avLst/>
@@ -8851,23 +8845,23 @@
           <a:p>
             <a:pPr algn="l">
               <a:lnSpc>
-                <a:spcPct val="110000"/>
-              </a:lnSpc>
-              <a:spcBef>
-                <a:spcPts val="0"/>
-              </a:spcBef>
-              <a:spcAft>
-                <a:spcPts val="400"/>
-              </a:spcAft>
-            </a:pPr>
-            <a:r>
-              <a:rPr sz="1450" b="0" i="0">
+                <a:spcPct val="100000"/>
+              </a:lnSpc>
+              <a:spcBef>
+                <a:spcPts val="0"/>
+              </a:spcBef>
+              <a:spcAft>
+                <a:spcPts val="400"/>
+              </a:spcAft>
+            </a:pPr>
+            <a:r>
+              <a:rPr sz="1400" b="0" i="0">
                 <a:solidFill>
                   <a:srgbClr val="F7F4EF"/>
                 </a:solidFill>
                 <a:latin typeface="Segoe UI"/>
               </a:rPr>
-              <a:t>Decide who owns AI, what data is in bounds, and where the guardrails are before you buy a seat. Two halves:</a:t>
+              <a:t>Decide who owns AI, what data is in bounds, and where the guardrails are before you buy a seat. Start with the people side.</a:t>
             </a:r>
           </a:p>
         </p:txBody>
@@ -8880,8 +8874,8 @@
         </p:nvSpPr>
         <p:spPr>
           <a:xfrm>
-            <a:off x="640080" y="2286000"/>
-            <a:ext cx="5394960" cy="3977639"/>
+            <a:off x="640080" y="2084831"/>
+            <a:ext cx="5349240" cy="1572768"/>
           </a:xfrm>
           <a:prstGeom prst="roundRect">
             <a:avLst>
@@ -8894,7 +8888,13 @@
           <a:ln>
             <a:noFill/>
           </a:ln>
-          <a:effectLst/>
+          <a:effectLst>
+            <a:outerShdw blurRad="90000" dist="38000" dir="5400000" rotWithShape="0">
+              <a:srgbClr val="000000">
+                <a:alpha val="13000"/>
+              </a:srgbClr>
+            </a:outerShdw>
+          </a:effectLst>
         </p:spPr>
         <p:style>
           <a:lnRef idx="1">
@@ -8920,59 +8920,14 @@
       </p:sp>
       <p:sp>
         <p:nvSpPr>
-          <p:cNvPr id="8" name="TextBox 7"/>
-          <p:cNvSpPr txBox="1"/>
-          <p:nvPr/>
-        </p:nvSpPr>
-        <p:spPr>
-          <a:xfrm>
-            <a:off x="960120" y="2514600"/>
-            <a:ext cx="4846320" cy="365760"/>
-          </a:xfrm>
-          <a:prstGeom prst="rect">
-            <a:avLst/>
-          </a:prstGeom>
-          <a:noFill/>
-        </p:spPr>
-        <p:txBody>
-          <a:bodyPr wrap="square" anchor="t" lIns="0" rIns="0" tIns="0" bIns="0">
-            <a:spAutoFit/>
-          </a:bodyPr>
-          <a:lstStyle/>
-          <a:p>
-            <a:pPr algn="l">
-              <a:lnSpc>
-                <a:spcPct val="100000"/>
-              </a:lnSpc>
-              <a:spcBef>
-                <a:spcPts val="0"/>
-              </a:spcBef>
-              <a:spcAft>
-                <a:spcPts val="400"/>
-              </a:spcAft>
-            </a:pPr>
-            <a:r>
-              <a:rPr sz="1250" b="1" i="0" spc="120">
-                <a:solidFill>
-                  <a:srgbClr val="FD8EA1"/>
-                </a:solidFill>
-                <a:latin typeface="Segoe UI Semibold"/>
-              </a:rPr>
-              <a:t>THE PEOPLE SIDE</a:t>
-            </a:r>
-          </a:p>
-        </p:txBody>
-      </p:sp>
-      <p:sp>
-        <p:nvSpPr>
-          <p:cNvPr id="9" name="Rectangle 8"/>
+          <p:cNvPr id="8" name="Rectangle 7"/>
           <p:cNvSpPr/>
           <p:nvPr/>
         </p:nvSpPr>
         <p:spPr>
           <a:xfrm>
-            <a:off x="960120" y="2980944"/>
-            <a:ext cx="128016" cy="128016"/>
+            <a:off x="960119" y="2377439"/>
+            <a:ext cx="457200" cy="82296"/>
           </a:xfrm>
           <a:prstGeom prst="rect">
             <a:avLst/>
@@ -9009,14 +8964,59 @@
       </p:sp>
       <p:sp>
         <p:nvSpPr>
+          <p:cNvPr id="9" name="TextBox 8"/>
+          <p:cNvSpPr txBox="1"/>
+          <p:nvPr/>
+        </p:nvSpPr>
+        <p:spPr>
+          <a:xfrm>
+            <a:off x="960119" y="2542032"/>
+            <a:ext cx="4709159" cy="365760"/>
+          </a:xfrm>
+          <a:prstGeom prst="rect">
+            <a:avLst/>
+          </a:prstGeom>
+          <a:noFill/>
+        </p:spPr>
+        <p:txBody>
+          <a:bodyPr wrap="square" anchor="t" lIns="0" rIns="0" tIns="0" bIns="0">
+            <a:spAutoFit/>
+          </a:bodyPr>
+          <a:lstStyle/>
+          <a:p>
+            <a:pPr algn="l">
+              <a:lnSpc>
+                <a:spcPct val="100000"/>
+              </a:lnSpc>
+              <a:spcBef>
+                <a:spcPts val="0"/>
+              </a:spcBef>
+              <a:spcAft>
+                <a:spcPts val="400"/>
+              </a:spcAft>
+            </a:pPr>
+            <a:r>
+              <a:rPr sz="1500" b="1" i="0">
+                <a:solidFill>
+                  <a:srgbClr val="FFFFFF"/>
+                </a:solidFill>
+                <a:latin typeface="Segoe UI Semibold"/>
+              </a:rPr>
+              <a:t>Stand up an AI governance committee</a:t>
+            </a:r>
+          </a:p>
+        </p:txBody>
+      </p:sp>
+      <p:sp>
+        <p:nvSpPr>
           <p:cNvPr id="10" name="TextBox 9"/>
           <p:cNvSpPr txBox="1"/>
           <p:nvPr/>
         </p:nvSpPr>
         <p:spPr>
           <a:xfrm>
-            <a:off x="1207008" y="2926080"/>
-            <a:ext cx="4663440" cy="292608"/>
+            <a:off x="960119" y="2926079"/>
+            <a:ext cx="4709159" cy="640080"/>
           </a:xfrm>
           <a:prstGeom prst="rect">
             <a:avLst/>
@@ -9031,52 +9031,7 @@
           <a:p>
             <a:pPr algn="l">
               <a:lnSpc>
-                <a:spcPct val="100000"/>
-              </a:lnSpc>
-              <a:spcBef>
-                <a:spcPts val="0"/>
-              </a:spcBef>
-              <a:spcAft>
-                <a:spcPts val="400"/>
-              </a:spcAft>
-            </a:pPr>
-            <a:r>
-              <a:rPr sz="1350" b="1" i="0">
-                <a:solidFill>
-                  <a:srgbClr val="FFFFFF"/>
-                </a:solidFill>
-                <a:latin typeface="Segoe UI Semibold"/>
-              </a:rPr>
-              <a:t>AI governance committee</a:t>
-            </a:r>
-          </a:p>
-        </p:txBody>
-      </p:sp>
-      <p:sp>
-        <p:nvSpPr>
-          <p:cNvPr id="11" name="TextBox 10"/>
-          <p:cNvSpPr txBox="1"/>
-          <p:nvPr/>
-        </p:nvSpPr>
-        <p:spPr>
-          <a:xfrm>
-            <a:off x="1207008" y="3218688"/>
-            <a:ext cx="4663440" cy="502920"/>
-          </a:xfrm>
-          <a:prstGeom prst="rect">
-            <a:avLst/>
-          </a:prstGeom>
-          <a:noFill/>
-        </p:spPr>
-        <p:txBody>
-          <a:bodyPr wrap="square" anchor="t" lIns="0" rIns="0" tIns="0" bIns="0">
-            <a:spAutoFit/>
-          </a:bodyPr>
-          <a:lstStyle/>
-          <a:p>
-            <a:pPr algn="l">
-              <a:lnSpc>
-                <a:spcPct val="105000"/>
+                <a:spcPct val="112000"/>
               </a:lnSpc>
               <a:spcBef>
                 <a:spcPts val="0"/>
@@ -9092,8 +9047,60 @@
                 </a:solidFill>
                 <a:latin typeface="Segoe UI"/>
               </a:rPr>
-              <a:t>One group owns the decisions: sponsor, IT, security, compliance, a business voice, HR.</a:t>
-            </a:r>
+              <a:t>One group owns the AI decisions: exec sponsor, IT, security, compliance, a business voice, HR. It owns acceptable use, data boundaries, and agent approval.</a:t>
+            </a:r>
+          </a:p>
+        </p:txBody>
+      </p:sp>
+      <p:sp>
+        <p:nvSpPr>
+          <p:cNvPr id="11" name="Rounded Rectangle 10"/>
+          <p:cNvSpPr/>
+          <p:nvPr/>
+        </p:nvSpPr>
+        <p:spPr>
+          <a:xfrm>
+            <a:off x="6199632" y="2084831"/>
+            <a:ext cx="5349240" cy="1572768"/>
+          </a:xfrm>
+          <a:prstGeom prst="roundRect">
+            <a:avLst>
+              <a:gd name="adj" fmla="val 6000"/>
+            </a:avLst>
+          </a:prstGeom>
+          <a:solidFill>
+            <a:srgbClr val="34312E"/>
+          </a:solidFill>
+          <a:ln>
+            <a:noFill/>
+          </a:ln>
+          <a:effectLst>
+            <a:outerShdw blurRad="90000" dist="38000" dir="5400000" rotWithShape="0">
+              <a:srgbClr val="000000">
+                <a:alpha val="13000"/>
+              </a:srgbClr>
+            </a:outerShdw>
+          </a:effectLst>
+        </p:spPr>
+        <p:style>
+          <a:lnRef idx="1">
+            <a:schemeClr val="accent1"/>
+          </a:lnRef>
+          <a:fillRef idx="3">
+            <a:schemeClr val="accent1"/>
+          </a:fillRef>
+          <a:effectRef idx="2">
+            <a:schemeClr val="accent1"/>
+          </a:effectRef>
+          <a:fontRef idx="minor">
+            <a:schemeClr val="lt1"/>
+          </a:fontRef>
+        </p:style>
+        <p:txBody>
+          <a:bodyPr rtlCol="0" anchor="ctr"/>
+          <a:lstStyle/>
+          <a:p>
+            <a:pPr algn="ctr"/>
           </a:p>
         </p:txBody>
       </p:sp>
@@ -9105,8 +9112,8 @@
         </p:nvSpPr>
         <p:spPr>
           <a:xfrm>
-            <a:off x="960120" y="3803904"/>
-            <a:ext cx="128016" cy="128016"/>
+            <a:off x="6519672" y="2377439"/>
+            <a:ext cx="457200" cy="82296"/>
           </a:xfrm>
           <a:prstGeom prst="rect">
             <a:avLst/>
@@ -9149,8 +9156,8 @@
         </p:nvSpPr>
         <p:spPr>
           <a:xfrm>
-            <a:off x="1207008" y="3749040"/>
-            <a:ext cx="4663440" cy="292608"/>
+            <a:off x="6519672" y="2542032"/>
+            <a:ext cx="4709159" cy="365760"/>
           </a:xfrm>
           <a:prstGeom prst="rect">
             <a:avLst/>
@@ -9175,13 +9182,13 @@
               </a:spcAft>
             </a:pPr>
             <a:r>
-              <a:rPr sz="1350" b="1" i="0">
+              <a:rPr sz="1500" b="1" i="0">
                 <a:solidFill>
                   <a:srgbClr val="FFFFFF"/>
                 </a:solidFill>
                 <a:latin typeface="Segoe UI Semibold"/>
               </a:rPr>
-              <a:t>AI in mission and strategy</a:t>
+              <a:t>Put AI in your mission and strategy</a:t>
             </a:r>
           </a:p>
         </p:txBody>
@@ -9194,8 +9201,8 @@
         </p:nvSpPr>
         <p:spPr>
           <a:xfrm>
-            <a:off x="1207008" y="4041648"/>
-            <a:ext cx="4663440" cy="502920"/>
+            <a:off x="6519672" y="2926079"/>
+            <a:ext cx="4709159" cy="640080"/>
           </a:xfrm>
           <a:prstGeom prst="rect">
             <a:avLst/>
@@ -9210,7 +9217,7 @@
           <a:p>
             <a:pPr algn="l">
               <a:lnSpc>
-                <a:spcPct val="105000"/>
+                <a:spcPct val="112000"/>
               </a:lnSpc>
               <a:spcBef>
                 <a:spcPts val="0"/>
@@ -9226,21 +9233,73 @@
                 </a:solidFill>
                 <a:latin typeface="Segoe UI"/>
               </a:rPr>
-              <a:t>Leadership frames it as how you work now, not a tool IT bought.</a:t>
-            </a:r>
-          </a:p>
-        </p:txBody>
-      </p:sp>
-      <p:sp>
-        <p:nvSpPr>
-          <p:cNvPr id="15" name="Rectangle 14"/>
+              <a:t>Leadership frames Copilot as how you work now, not a tool IT bought. Tie it to outcomes leaders already care about: time back, lower cost, better care.</a:t>
+            </a:r>
+          </a:p>
+        </p:txBody>
+      </p:sp>
+      <p:sp>
+        <p:nvSpPr>
+          <p:cNvPr id="15" name="Rounded Rectangle 14"/>
           <p:cNvSpPr/>
           <p:nvPr/>
         </p:nvSpPr>
         <p:spPr>
           <a:xfrm>
-            <a:off x="960120" y="4626864"/>
-            <a:ext cx="128016" cy="128016"/>
+            <a:off x="640080" y="3867911"/>
+            <a:ext cx="5349240" cy="1572768"/>
+          </a:xfrm>
+          <a:prstGeom prst="roundRect">
+            <a:avLst>
+              <a:gd name="adj" fmla="val 6000"/>
+            </a:avLst>
+          </a:prstGeom>
+          <a:solidFill>
+            <a:srgbClr val="34312E"/>
+          </a:solidFill>
+          <a:ln>
+            <a:noFill/>
+          </a:ln>
+          <a:effectLst>
+            <a:outerShdw blurRad="90000" dist="38000" dir="5400000" rotWithShape="0">
+              <a:srgbClr val="000000">
+                <a:alpha val="13000"/>
+              </a:srgbClr>
+            </a:outerShdw>
+          </a:effectLst>
+        </p:spPr>
+        <p:style>
+          <a:lnRef idx="1">
+            <a:schemeClr val="accent1"/>
+          </a:lnRef>
+          <a:fillRef idx="3">
+            <a:schemeClr val="accent1"/>
+          </a:fillRef>
+          <a:effectRef idx="2">
+            <a:schemeClr val="accent1"/>
+          </a:effectRef>
+          <a:fontRef idx="minor">
+            <a:schemeClr val="lt1"/>
+          </a:fontRef>
+        </p:style>
+        <p:txBody>
+          <a:bodyPr rtlCol="0" anchor="ctr"/>
+          <a:lstStyle/>
+          <a:p>
+            <a:pPr algn="ctr"/>
+          </a:p>
+        </p:txBody>
+      </p:sp>
+      <p:sp>
+        <p:nvSpPr>
+          <p:cNvPr id="16" name="Rectangle 15"/>
+          <p:cNvSpPr/>
+          <p:nvPr/>
+        </p:nvSpPr>
+        <p:spPr>
+          <a:xfrm>
+            <a:off x="960119" y="4160520"/>
+            <a:ext cx="457200" cy="82296"/>
           </a:xfrm>
           <a:prstGeom prst="rect">
             <a:avLst/>
@@ -9277,14 +9336,14 @@
       </p:sp>
       <p:sp>
         <p:nvSpPr>
-          <p:cNvPr id="16" name="TextBox 15"/>
-          <p:cNvSpPr txBox="1"/>
-          <p:nvPr/>
-        </p:nvSpPr>
-        <p:spPr>
-          <a:xfrm>
-            <a:off x="1207008" y="4572000"/>
-            <a:ext cx="4663440" cy="292608"/>
+          <p:cNvPr id="17" name="TextBox 16"/>
+          <p:cNvSpPr txBox="1"/>
+          <p:nvPr/>
+        </p:nvSpPr>
+        <p:spPr>
+          <a:xfrm>
+            <a:off x="960119" y="4325112"/>
+            <a:ext cx="4709159" cy="365760"/>
           </a:xfrm>
           <a:prstGeom prst="rect">
             <a:avLst/>
@@ -9309,27 +9368,27 @@
               </a:spcAft>
             </a:pPr>
             <a:r>
-              <a:rPr sz="1350" b="1" i="0">
+              <a:rPr sz="1500" b="1" i="0">
                 <a:solidFill>
                   <a:srgbClr val="FFFFFF"/>
                 </a:solidFill>
                 <a:latin typeface="Segoe UI Semibold"/>
               </a:rPr>
-              <a:t>Culture from the top</a:t>
-            </a:r>
-          </a:p>
-        </p:txBody>
-      </p:sp>
-      <p:sp>
-        <p:nvSpPr>
-          <p:cNvPr id="17" name="TextBox 16"/>
-          <p:cNvSpPr txBox="1"/>
-          <p:nvPr/>
-        </p:nvSpPr>
-        <p:spPr>
-          <a:xfrm>
-            <a:off x="1207008" y="4864608"/>
-            <a:ext cx="4663440" cy="502920"/>
+              <a:t>Drive culture from the top</a:t>
+            </a:r>
+          </a:p>
+        </p:txBody>
+      </p:sp>
+      <p:sp>
+        <p:nvSpPr>
+          <p:cNvPr id="18" name="TextBox 17"/>
+          <p:cNvSpPr txBox="1"/>
+          <p:nvPr/>
+        </p:nvSpPr>
+        <p:spPr>
+          <a:xfrm>
+            <a:off x="960119" y="4709159"/>
+            <a:ext cx="4709159" cy="640080"/>
           </a:xfrm>
           <a:prstGeom prst="rect">
             <a:avLst/>
@@ -9344,7 +9403,7 @@
           <a:p>
             <a:pPr algn="l">
               <a:lnSpc>
-                <a:spcPct val="105000"/>
+                <a:spcPct val="112000"/>
               </a:lnSpc>
               <a:spcBef>
                 <a:spcPts val="0"/>
@@ -9360,21 +9419,73 @@
                 </a:solidFill>
                 <a:latin typeface="Segoe UI"/>
               </a:rPr>
-              <a:t>Change management is a leadership job, not a training deck.</a:t>
-            </a:r>
-          </a:p>
-        </p:txBody>
-      </p:sp>
-      <p:sp>
-        <p:nvSpPr>
-          <p:cNvPr id="18" name="Rectangle 17"/>
+              <a:t>Change management is a leadership job, not a training deck. Executives model the behavior and give people time to build the habit.</a:t>
+            </a:r>
+          </a:p>
+        </p:txBody>
+      </p:sp>
+      <p:sp>
+        <p:nvSpPr>
+          <p:cNvPr id="19" name="Rounded Rectangle 18"/>
           <p:cNvSpPr/>
           <p:nvPr/>
         </p:nvSpPr>
         <p:spPr>
           <a:xfrm>
-            <a:off x="960120" y="5449824"/>
-            <a:ext cx="128016" cy="128016"/>
+            <a:off x="6199632" y="3867911"/>
+            <a:ext cx="5349240" cy="1572768"/>
+          </a:xfrm>
+          <a:prstGeom prst="roundRect">
+            <a:avLst>
+              <a:gd name="adj" fmla="val 6000"/>
+            </a:avLst>
+          </a:prstGeom>
+          <a:solidFill>
+            <a:srgbClr val="34312E"/>
+          </a:solidFill>
+          <a:ln>
+            <a:noFill/>
+          </a:ln>
+          <a:effectLst>
+            <a:outerShdw blurRad="90000" dist="38000" dir="5400000" rotWithShape="0">
+              <a:srgbClr val="000000">
+                <a:alpha val="13000"/>
+              </a:srgbClr>
+            </a:outerShdw>
+          </a:effectLst>
+        </p:spPr>
+        <p:style>
+          <a:lnRef idx="1">
+            <a:schemeClr val="accent1"/>
+          </a:lnRef>
+          <a:fillRef idx="3">
+            <a:schemeClr val="accent1"/>
+          </a:fillRef>
+          <a:effectRef idx="2">
+            <a:schemeClr val="accent1"/>
+          </a:effectRef>
+          <a:fontRef idx="minor">
+            <a:schemeClr val="lt1"/>
+          </a:fontRef>
+        </p:style>
+        <p:txBody>
+          <a:bodyPr rtlCol="0" anchor="ctr"/>
+          <a:lstStyle/>
+          <a:p>
+            <a:pPr algn="ctr"/>
+          </a:p>
+        </p:txBody>
+      </p:sp>
+      <p:sp>
+        <p:nvSpPr>
+          <p:cNvPr id="20" name="Rectangle 19"/>
+          <p:cNvSpPr/>
+          <p:nvPr/>
+        </p:nvSpPr>
+        <p:spPr>
+          <a:xfrm>
+            <a:off x="6519672" y="4160520"/>
+            <a:ext cx="457200" cy="82296"/>
           </a:xfrm>
           <a:prstGeom prst="rect">
             <a:avLst/>
@@ -9411,14 +9522,14 @@
       </p:sp>
       <p:sp>
         <p:nvSpPr>
-          <p:cNvPr id="19" name="TextBox 18"/>
-          <p:cNvSpPr txBox="1"/>
-          <p:nvPr/>
-        </p:nvSpPr>
-        <p:spPr>
-          <a:xfrm>
-            <a:off x="1207008" y="5394960"/>
-            <a:ext cx="4663440" cy="292608"/>
+          <p:cNvPr id="21" name="TextBox 20"/>
+          <p:cNvSpPr txBox="1"/>
+          <p:nvPr/>
+        </p:nvSpPr>
+        <p:spPr>
+          <a:xfrm>
+            <a:off x="6519672" y="4325112"/>
+            <a:ext cx="4709159" cy="365760"/>
           </a:xfrm>
           <a:prstGeom prst="rect">
             <a:avLst/>
@@ -9443,27 +9554,27 @@
               </a:spcAft>
             </a:pPr>
             <a:r>
-              <a:rPr sz="1350" b="1" i="0">
+              <a:rPr sz="1500" b="1" i="0">
                 <a:solidFill>
                   <a:srgbClr val="FFFFFF"/>
                 </a:solidFill>
                 <a:latin typeface="Segoe UI Semibold"/>
               </a:rPr>
-              <a:t>A champion network</a:t>
-            </a:r>
-          </a:p>
-        </p:txBody>
-      </p:sp>
-      <p:sp>
-        <p:nvSpPr>
-          <p:cNvPr id="20" name="TextBox 19"/>
-          <p:cNvSpPr txBox="1"/>
-          <p:nvPr/>
-        </p:nvSpPr>
-        <p:spPr>
-          <a:xfrm>
-            <a:off x="1207008" y="5687568"/>
-            <a:ext cx="4663440" cy="502920"/>
+              <a:t>Build a champion network</a:t>
+            </a:r>
+          </a:p>
+        </p:txBody>
+      </p:sp>
+      <p:sp>
+        <p:nvSpPr>
+          <p:cNvPr id="22" name="TextBox 21"/>
+          <p:cNvSpPr txBox="1"/>
+          <p:nvPr/>
+        </p:nvSpPr>
+        <p:spPr>
+          <a:xfrm>
+            <a:off x="6519672" y="4709159"/>
+            <a:ext cx="4709159" cy="640080"/>
           </a:xfrm>
           <a:prstGeom prst="rect">
             <a:avLst/>
@@ -9478,7 +9589,7 @@
           <a:p>
             <a:pPr algn="l">
               <a:lnSpc>
-                <a:spcPct val="105000"/>
+                <a:spcPct val="112000"/>
               </a:lnSpc>
               <a:spcBef>
                 <a:spcPts val="0"/>
@@ -9494,21 +9605,21 @@
                 </a:solidFill>
                 <a:latin typeface="Segoe UI"/>
               </a:rPr>
-              <a:t>The bottom-up engine that pairs with top-down sponsorship.</a:t>
-            </a:r>
-          </a:p>
-        </p:txBody>
-      </p:sp>
-      <p:sp>
-        <p:nvSpPr>
-          <p:cNvPr id="21" name="Rounded Rectangle 20"/>
+              <a:t>A few enthusiastic peers per department move adoption further than any mandate. The Copilot Success Kit and Academy arm them.</a:t>
+            </a:r>
+          </a:p>
+        </p:txBody>
+      </p:sp>
+      <p:sp>
+        <p:nvSpPr>
+          <p:cNvPr id="23" name="Rounded Rectangle 22"/>
           <p:cNvSpPr/>
           <p:nvPr/>
         </p:nvSpPr>
         <p:spPr>
           <a:xfrm>
-            <a:off x="6172200" y="2286000"/>
-            <a:ext cx="5376672" cy="3977639"/>
+            <a:off x="640080" y="5669279"/>
+            <a:ext cx="10908792" cy="603504"/>
           </a:xfrm>
           <a:prstGeom prst="roundRect">
             <a:avLst>
@@ -9516,7 +9627,7 @@
             </a:avLst>
           </a:prstGeom>
           <a:solidFill>
-            <a:srgbClr val="34312E"/>
+            <a:srgbClr val="B11F4B"/>
           </a:solidFill>
           <a:ln>
             <a:noFill/>
@@ -9547,22 +9658,22 @@
       </p:sp>
       <p:sp>
         <p:nvSpPr>
-          <p:cNvPr id="22" name="TextBox 21"/>
-          <p:cNvSpPr txBox="1"/>
-          <p:nvPr/>
-        </p:nvSpPr>
-        <p:spPr>
-          <a:xfrm>
-            <a:off x="6492240" y="2514600"/>
-            <a:ext cx="4846320" cy="365760"/>
-          </a:xfrm>
-          <a:prstGeom prst="rect">
-            <a:avLst/>
-          </a:prstGeom>
-          <a:noFill/>
-        </p:spPr>
-        <p:txBody>
-          <a:bodyPr wrap="square" anchor="t" lIns="0" rIns="0" tIns="0" bIns="0">
+          <p:cNvPr id="24" name="TextBox 23"/>
+          <p:cNvSpPr txBox="1"/>
+          <p:nvPr/>
+        </p:nvSpPr>
+        <p:spPr>
+          <a:xfrm>
+            <a:off x="932688" y="5669279"/>
+            <a:ext cx="10424160" cy="603504"/>
+          </a:xfrm>
+          <a:prstGeom prst="rect">
+            <a:avLst/>
+          </a:prstGeom>
+          <a:noFill/>
+        </p:spPr>
+        <p:txBody>
+          <a:bodyPr wrap="square" anchor="ctr" lIns="0" rIns="0" tIns="0" bIns="0">
             <a:spAutoFit/>
           </a:bodyPr>
           <a:lstStyle/>
@@ -9579,549 +9690,22 @@
               </a:spcAft>
             </a:pPr>
             <a:r>
-              <a:rPr sz="1250" b="1" i="0" spc="120">
+              <a:rPr sz="1150" b="1" i="0">
+                <a:solidFill>
+                  <a:srgbClr val="FFFFFF"/>
+                </a:solidFill>
+                <a:latin typeface="Segoe UI"/>
+              </a:rPr>
+              <a:t>Then the platform side:  </a:t>
+            </a:r>
+            <a:r>
+              <a:rPr sz="1150" b="0" i="0">
                 <a:solidFill>
                   <a:srgbClr val="FD8EA1"/>
                 </a:solidFill>
-                <a:latin typeface="Segoe UI Semibold"/>
-              </a:rPr>
-              <a:t>THE PLATFORM SIDE</a:t>
-            </a:r>
-          </a:p>
-        </p:txBody>
-      </p:sp>
-      <p:sp>
-        <p:nvSpPr>
-          <p:cNvPr id="23" name="Rectangle 22"/>
-          <p:cNvSpPr/>
-          <p:nvPr/>
-        </p:nvSpPr>
-        <p:spPr>
-          <a:xfrm>
-            <a:off x="6492240" y="2980944"/>
-            <a:ext cx="128016" cy="128016"/>
-          </a:xfrm>
-          <a:prstGeom prst="rect">
-            <a:avLst/>
-          </a:prstGeom>
-          <a:solidFill>
-            <a:srgbClr val="FD8EA1"/>
-          </a:solidFill>
-          <a:ln>
-            <a:noFill/>
-          </a:ln>
-          <a:effectLst/>
-        </p:spPr>
-        <p:style>
-          <a:lnRef idx="1">
-            <a:schemeClr val="accent1"/>
-          </a:lnRef>
-          <a:fillRef idx="3">
-            <a:schemeClr val="accent1"/>
-          </a:fillRef>
-          <a:effectRef idx="2">
-            <a:schemeClr val="accent1"/>
-          </a:effectRef>
-          <a:fontRef idx="minor">
-            <a:schemeClr val="lt1"/>
-          </a:fontRef>
-        </p:style>
-        <p:txBody>
-          <a:bodyPr rtlCol="0" anchor="ctr"/>
-          <a:lstStyle/>
-          <a:p>
-            <a:pPr algn="ctr"/>
-          </a:p>
-        </p:txBody>
-      </p:sp>
-      <p:sp>
-        <p:nvSpPr>
-          <p:cNvPr id="24" name="TextBox 23"/>
-          <p:cNvSpPr txBox="1"/>
-          <p:nvPr/>
-        </p:nvSpPr>
-        <p:spPr>
-          <a:xfrm>
-            <a:off x="6739128" y="2926080"/>
-            <a:ext cx="4663440" cy="292608"/>
-          </a:xfrm>
-          <a:prstGeom prst="rect">
-            <a:avLst/>
-          </a:prstGeom>
-          <a:noFill/>
-        </p:spPr>
-        <p:txBody>
-          <a:bodyPr wrap="square" anchor="t" lIns="0" rIns="0" tIns="0" bIns="0">
-            <a:spAutoFit/>
-          </a:bodyPr>
-          <a:lstStyle/>
-          <a:p>
-            <a:pPr algn="l">
-              <a:lnSpc>
-                <a:spcPct val="100000"/>
-              </a:lnSpc>
-              <a:spcBef>
-                <a:spcPts val="0"/>
-              </a:spcBef>
-              <a:spcAft>
-                <a:spcPts val="400"/>
-              </a:spcAft>
-            </a:pPr>
-            <a:r>
-              <a:rPr sz="1350" b="1" i="0">
-                <a:solidFill>
-                  <a:srgbClr val="FFFFFF"/>
-                </a:solidFill>
-                <a:latin typeface="Segoe UI Semibold"/>
-              </a:rPr>
-              <a:t>SharePoint Advanced Mgmt</a:t>
-            </a:r>
-          </a:p>
-        </p:txBody>
-      </p:sp>
-      <p:sp>
-        <p:nvSpPr>
-          <p:cNvPr id="25" name="TextBox 24"/>
-          <p:cNvSpPr txBox="1"/>
-          <p:nvPr/>
-        </p:nvSpPr>
-        <p:spPr>
-          <a:xfrm>
-            <a:off x="6739128" y="3218688"/>
-            <a:ext cx="4663440" cy="502920"/>
-          </a:xfrm>
-          <a:prstGeom prst="rect">
-            <a:avLst/>
-          </a:prstGeom>
-          <a:noFill/>
-        </p:spPr>
-        <p:txBody>
-          <a:bodyPr wrap="square" anchor="t" lIns="0" rIns="0" tIns="0" bIns="0">
-            <a:spAutoFit/>
-          </a:bodyPr>
-          <a:lstStyle/>
-          <a:p>
-            <a:pPr algn="l">
-              <a:lnSpc>
-                <a:spcPct val="105000"/>
-              </a:lnSpc>
-              <a:spcBef>
-                <a:spcPts val="0"/>
-              </a:spcBef>
-              <a:spcAft>
-                <a:spcPts val="400"/>
-              </a:spcAft>
-            </a:pPr>
-            <a:r>
-              <a:rPr sz="1150" b="0" i="0">
-                <a:solidFill>
-                  <a:srgbClr val="F7F4EF"/>
-                </a:solidFill>
                 <a:latin typeface="Segoe UI"/>
               </a:rPr>
-              <a:t>Comes with your paid seat. RCD + Data Access Governance to fix oversharing.</a:t>
-            </a:r>
-          </a:p>
-        </p:txBody>
-      </p:sp>
-      <p:sp>
-        <p:nvSpPr>
-          <p:cNvPr id="26" name="Rectangle 25"/>
-          <p:cNvSpPr/>
-          <p:nvPr/>
-        </p:nvSpPr>
-        <p:spPr>
-          <a:xfrm>
-            <a:off x="6492240" y="3803904"/>
-            <a:ext cx="128016" cy="128016"/>
-          </a:xfrm>
-          <a:prstGeom prst="rect">
-            <a:avLst/>
-          </a:prstGeom>
-          <a:solidFill>
-            <a:srgbClr val="FD8EA1"/>
-          </a:solidFill>
-          <a:ln>
-            <a:noFill/>
-          </a:ln>
-          <a:effectLst/>
-        </p:spPr>
-        <p:style>
-          <a:lnRef idx="1">
-            <a:schemeClr val="accent1"/>
-          </a:lnRef>
-          <a:fillRef idx="3">
-            <a:schemeClr val="accent1"/>
-          </a:fillRef>
-          <a:effectRef idx="2">
-            <a:schemeClr val="accent1"/>
-          </a:effectRef>
-          <a:fontRef idx="minor">
-            <a:schemeClr val="lt1"/>
-          </a:fontRef>
-        </p:style>
-        <p:txBody>
-          <a:bodyPr rtlCol="0" anchor="ctr"/>
-          <a:lstStyle/>
-          <a:p>
-            <a:pPr algn="ctr"/>
-          </a:p>
-        </p:txBody>
-      </p:sp>
-      <p:sp>
-        <p:nvSpPr>
-          <p:cNvPr id="27" name="TextBox 26"/>
-          <p:cNvSpPr txBox="1"/>
-          <p:nvPr/>
-        </p:nvSpPr>
-        <p:spPr>
-          <a:xfrm>
-            <a:off x="6739128" y="3749040"/>
-            <a:ext cx="4663440" cy="292608"/>
-          </a:xfrm>
-          <a:prstGeom prst="rect">
-            <a:avLst/>
-          </a:prstGeom>
-          <a:noFill/>
-        </p:spPr>
-        <p:txBody>
-          <a:bodyPr wrap="square" anchor="t" lIns="0" rIns="0" tIns="0" bIns="0">
-            <a:spAutoFit/>
-          </a:bodyPr>
-          <a:lstStyle/>
-          <a:p>
-            <a:pPr algn="l">
-              <a:lnSpc>
-                <a:spcPct val="100000"/>
-              </a:lnSpc>
-              <a:spcBef>
-                <a:spcPts val="0"/>
-              </a:spcBef>
-              <a:spcAft>
-                <a:spcPts val="400"/>
-              </a:spcAft>
-            </a:pPr>
-            <a:r>
-              <a:rPr sz="1350" b="1" i="0">
-                <a:solidFill>
-                  <a:srgbClr val="FFFFFF"/>
-                </a:solidFill>
-                <a:latin typeface="Segoe UI Semibold"/>
-              </a:rPr>
-              <a:t>Microsoft Purview</a:t>
-            </a:r>
-          </a:p>
-        </p:txBody>
-      </p:sp>
-      <p:sp>
-        <p:nvSpPr>
-          <p:cNvPr id="28" name="TextBox 27"/>
-          <p:cNvSpPr txBox="1"/>
-          <p:nvPr/>
-        </p:nvSpPr>
-        <p:spPr>
-          <a:xfrm>
-            <a:off x="6739128" y="4041648"/>
-            <a:ext cx="4663440" cy="502920"/>
-          </a:xfrm>
-          <a:prstGeom prst="rect">
-            <a:avLst/>
-          </a:prstGeom>
-          <a:noFill/>
-        </p:spPr>
-        <p:txBody>
-          <a:bodyPr wrap="square" anchor="t" lIns="0" rIns="0" tIns="0" bIns="0">
-            <a:spAutoFit/>
-          </a:bodyPr>
-          <a:lstStyle/>
-          <a:p>
-            <a:pPr algn="l">
-              <a:lnSpc>
-                <a:spcPct val="105000"/>
-              </a:lnSpc>
-              <a:spcBef>
-                <a:spcPts val="0"/>
-              </a:spcBef>
-              <a:spcAft>
-                <a:spcPts val="400"/>
-              </a:spcAft>
-            </a:pPr>
-            <a:r>
-              <a:rPr sz="1150" b="0" i="0">
-                <a:solidFill>
-                  <a:srgbClr val="F7F4EF"/>
-                </a:solidFill>
-                <a:latin typeface="Segoe UI"/>
-              </a:rPr>
-              <a:t>Sensitivity labels, DSPM for AI, audit. Depends on your Purview / E5 licensing.</a:t>
-            </a:r>
-          </a:p>
-        </p:txBody>
-      </p:sp>
-      <p:sp>
-        <p:nvSpPr>
-          <p:cNvPr id="29" name="Rectangle 28"/>
-          <p:cNvSpPr/>
-          <p:nvPr/>
-        </p:nvSpPr>
-        <p:spPr>
-          <a:xfrm>
-            <a:off x="6492240" y="4626864"/>
-            <a:ext cx="128016" cy="128016"/>
-          </a:xfrm>
-          <a:prstGeom prst="rect">
-            <a:avLst/>
-          </a:prstGeom>
-          <a:solidFill>
-            <a:srgbClr val="FD8EA1"/>
-          </a:solidFill>
-          <a:ln>
-            <a:noFill/>
-          </a:ln>
-          <a:effectLst/>
-        </p:spPr>
-        <p:style>
-          <a:lnRef idx="1">
-            <a:schemeClr val="accent1"/>
-          </a:lnRef>
-          <a:fillRef idx="3">
-            <a:schemeClr val="accent1"/>
-          </a:fillRef>
-          <a:effectRef idx="2">
-            <a:schemeClr val="accent1"/>
-          </a:effectRef>
-          <a:fontRef idx="minor">
-            <a:schemeClr val="lt1"/>
-          </a:fontRef>
-        </p:style>
-        <p:txBody>
-          <a:bodyPr rtlCol="0" anchor="ctr"/>
-          <a:lstStyle/>
-          <a:p>
-            <a:pPr algn="ctr"/>
-          </a:p>
-        </p:txBody>
-      </p:sp>
-      <p:sp>
-        <p:nvSpPr>
-          <p:cNvPr id="30" name="TextBox 29"/>
-          <p:cNvSpPr txBox="1"/>
-          <p:nvPr/>
-        </p:nvSpPr>
-        <p:spPr>
-          <a:xfrm>
-            <a:off x="6739128" y="4572000"/>
-            <a:ext cx="4663440" cy="292608"/>
-          </a:xfrm>
-          <a:prstGeom prst="rect">
-            <a:avLst/>
-          </a:prstGeom>
-          <a:noFill/>
-        </p:spPr>
-        <p:txBody>
-          <a:bodyPr wrap="square" anchor="t" lIns="0" rIns="0" tIns="0" bIns="0">
-            <a:spAutoFit/>
-          </a:bodyPr>
-          <a:lstStyle/>
-          <a:p>
-            <a:pPr algn="l">
-              <a:lnSpc>
-                <a:spcPct val="100000"/>
-              </a:lnSpc>
-              <a:spcBef>
-                <a:spcPts val="0"/>
-              </a:spcBef>
-              <a:spcAft>
-                <a:spcPts val="400"/>
-              </a:spcAft>
-            </a:pPr>
-            <a:r>
-              <a:rPr sz="1350" b="1" i="0">
-                <a:solidFill>
-                  <a:srgbClr val="FFFFFF"/>
-                </a:solidFill>
-                <a:latin typeface="Segoe UI Semibold"/>
-              </a:rPr>
-              <a:t>Agent Registry + Agent 365</a:t>
-            </a:r>
-          </a:p>
-        </p:txBody>
-      </p:sp>
-      <p:sp>
-        <p:nvSpPr>
-          <p:cNvPr id="31" name="TextBox 30"/>
-          <p:cNvSpPr txBox="1"/>
-          <p:nvPr/>
-        </p:nvSpPr>
-        <p:spPr>
-          <a:xfrm>
-            <a:off x="6739128" y="4864608"/>
-            <a:ext cx="4663440" cy="502920"/>
-          </a:xfrm>
-          <a:prstGeom prst="rect">
-            <a:avLst/>
-          </a:prstGeom>
-          <a:noFill/>
-        </p:spPr>
-        <p:txBody>
-          <a:bodyPr wrap="square" anchor="t" lIns="0" rIns="0" tIns="0" bIns="0">
-            <a:spAutoFit/>
-          </a:bodyPr>
-          <a:lstStyle/>
-          <a:p>
-            <a:pPr algn="l">
-              <a:lnSpc>
-                <a:spcPct val="105000"/>
-              </a:lnSpc>
-              <a:spcBef>
-                <a:spcPts val="0"/>
-              </a:spcBef>
-              <a:spcAft>
-                <a:spcPts val="400"/>
-              </a:spcAft>
-            </a:pPr>
-            <a:r>
-              <a:rPr sz="1150" b="0" i="0">
-                <a:solidFill>
-                  <a:srgbClr val="F7F4EF"/>
-                </a:solidFill>
-                <a:latin typeface="Segoe UI"/>
-              </a:rPr>
-              <a:t>One inventory to observe, approve, block, and secure agents.</a:t>
-            </a:r>
-          </a:p>
-        </p:txBody>
-      </p:sp>
-      <p:sp>
-        <p:nvSpPr>
-          <p:cNvPr id="32" name="Rectangle 31"/>
-          <p:cNvSpPr/>
-          <p:nvPr/>
-        </p:nvSpPr>
-        <p:spPr>
-          <a:xfrm>
-            <a:off x="6492240" y="5449824"/>
-            <a:ext cx="128016" cy="128016"/>
-          </a:xfrm>
-          <a:prstGeom prst="rect">
-            <a:avLst/>
-          </a:prstGeom>
-          <a:solidFill>
-            <a:srgbClr val="FD8EA1"/>
-          </a:solidFill>
-          <a:ln>
-            <a:noFill/>
-          </a:ln>
-          <a:effectLst/>
-        </p:spPr>
-        <p:style>
-          <a:lnRef idx="1">
-            <a:schemeClr val="accent1"/>
-          </a:lnRef>
-          <a:fillRef idx="3">
-            <a:schemeClr val="accent1"/>
-          </a:fillRef>
-          <a:effectRef idx="2">
-            <a:schemeClr val="accent1"/>
-          </a:effectRef>
-          <a:fontRef idx="minor">
-            <a:schemeClr val="lt1"/>
-          </a:fontRef>
-        </p:style>
-        <p:txBody>
-          <a:bodyPr rtlCol="0" anchor="ctr"/>
-          <a:lstStyle/>
-          <a:p>
-            <a:pPr algn="ctr"/>
-          </a:p>
-        </p:txBody>
-      </p:sp>
-      <p:sp>
-        <p:nvSpPr>
-          <p:cNvPr id="33" name="TextBox 32"/>
-          <p:cNvSpPr txBox="1"/>
-          <p:nvPr/>
-        </p:nvSpPr>
-        <p:spPr>
-          <a:xfrm>
-            <a:off x="6739128" y="5394960"/>
-            <a:ext cx="4663440" cy="292608"/>
-          </a:xfrm>
-          <a:prstGeom prst="rect">
-            <a:avLst/>
-          </a:prstGeom>
-          <a:noFill/>
-        </p:spPr>
-        <p:txBody>
-          <a:bodyPr wrap="square" anchor="t" lIns="0" rIns="0" tIns="0" bIns="0">
-            <a:spAutoFit/>
-          </a:bodyPr>
-          <a:lstStyle/>
-          <a:p>
-            <a:pPr algn="l">
-              <a:lnSpc>
-                <a:spcPct val="100000"/>
-              </a:lnSpc>
-              <a:spcBef>
-                <a:spcPts val="0"/>
-              </a:spcBef>
-              <a:spcAft>
-                <a:spcPts val="400"/>
-              </a:spcAft>
-            </a:pPr>
-            <a:r>
-              <a:rPr sz="1350" b="1" i="0">
-                <a:solidFill>
-                  <a:srgbClr val="FFFFFF"/>
-                </a:solidFill>
-                <a:latin typeface="Segoe UI Semibold"/>
-              </a:rPr>
-              <a:t>Least privilege</a:t>
-            </a:r>
-          </a:p>
-        </p:txBody>
-      </p:sp>
-      <p:sp>
-        <p:nvSpPr>
-          <p:cNvPr id="34" name="TextBox 33"/>
-          <p:cNvSpPr txBox="1"/>
-          <p:nvPr/>
-        </p:nvSpPr>
-        <p:spPr>
-          <a:xfrm>
-            <a:off x="6739128" y="5687568"/>
-            <a:ext cx="4663440" cy="502920"/>
-          </a:xfrm>
-          <a:prstGeom prst="rect">
-            <a:avLst/>
-          </a:prstGeom>
-          <a:noFill/>
-        </p:spPr>
-        <p:txBody>
-          <a:bodyPr wrap="square" anchor="t" lIns="0" rIns="0" tIns="0" bIns="0">
-            <a:spAutoFit/>
-          </a:bodyPr>
-          <a:lstStyle/>
-          <a:p>
-            <a:pPr algn="l">
-              <a:lnSpc>
-                <a:spcPct val="105000"/>
-              </a:lnSpc>
-              <a:spcBef>
-                <a:spcPts val="0"/>
-              </a:spcBef>
-              <a:spcAft>
-                <a:spcPts val="400"/>
-              </a:spcAft>
-            </a:pPr>
-            <a:r>
-              <a:rPr sz="1150" b="0" i="0">
-                <a:solidFill>
-                  <a:srgbClr val="F7F4EF"/>
-                </a:solidFill>
-                <a:latin typeface="Segoe UI"/>
-              </a:rPr>
-              <a:t>Run agent governance with the AI Administrator role, not Global Admin.</a:t>
+              <a:t>SharePoint Advanced Management (included) + RCD  ·  Purview  ·  Agent Registry / Agent 365  ·  AI Administrator, least privilege</a:t>
             </a:r>
           </a:p>
         </p:txBody>
@@ -10344,7 +9928,6 @@
           <a:ln>
             <a:noFill/>
           </a:ln>
-          <a:effectLst/>
           <a:effectLst>
             <a:outerShdw blurRad="90000" dist="38000" dir="5400000" rotWithShape="0">
               <a:srgbClr val="000000">
@@ -10486,7 +10069,6 @@
           <a:ln>
             <a:noFill/>
           </a:ln>
-          <a:effectLst/>
           <a:effectLst>
             <a:outerShdw blurRad="90000" dist="38000" dir="5400000" rotWithShape="0">
               <a:srgbClr val="000000">
@@ -11859,7 +11441,6 @@
           <a:ln>
             <a:noFill/>
           </a:ln>
-          <a:effectLst/>
           <a:effectLst>
             <a:outerShdw blurRad="90000" dist="38000" dir="5400000" rotWithShape="0">
               <a:srgbClr val="000000">
@@ -12271,7 +11852,6 @@
           <a:ln>
             <a:noFill/>
           </a:ln>
-          <a:effectLst/>
           <a:effectLst>
             <a:outerShdw blurRad="90000" dist="38000" dir="5400000" rotWithShape="0">
               <a:srgbClr val="000000">
@@ -12683,7 +12263,6 @@
           <a:ln>
             <a:noFill/>
           </a:ln>
-          <a:effectLst/>
           <a:effectLst>
             <a:outerShdw blurRad="90000" dist="38000" dir="5400000" rotWithShape="0">
               <a:srgbClr val="000000">
@@ -13717,7 +13296,7 @@
                 </a:solidFill>
                 <a:latin typeface="Segoe UI Semibold"/>
               </a:rPr>
-              <a:t>THREE DATED ITEMS TO HANDLE</a:t>
+              <a:t>COMPLIANCE GUARDRAILS</a:t>
             </a:r>
           </a:p>
         </p:txBody>
@@ -13731,7 +13310,7 @@
         <p:spPr>
           <a:xfrm>
             <a:off x="6858000" y="2450592"/>
-            <a:ext cx="1051560" cy="384048"/>
+            <a:ext cx="1234440" cy="384048"/>
           </a:xfrm>
           <a:prstGeom prst="roundRect">
             <a:avLst>
@@ -13777,7 +13356,7 @@
         <p:spPr>
           <a:xfrm>
             <a:off x="6858000" y="2450592"/>
-            <a:ext cx="1051560" cy="384048"/>
+            <a:ext cx="1234440" cy="384048"/>
           </a:xfrm>
           <a:prstGeom prst="rect">
             <a:avLst/>
@@ -13802,13 +13381,13 @@
               </a:spcAft>
             </a:pPr>
             <a:r>
-              <a:rPr sz="1250" b="1" i="0">
+              <a:rPr sz="1200" b="1" i="0">
                 <a:solidFill>
                   <a:srgbClr val="FFFFFF"/>
                 </a:solidFill>
                 <a:latin typeface="Segoe UI Semibold"/>
               </a:rPr>
-              <a:t>July 24</a:t>
+              <a:t>Week 1</a:t>
             </a:r>
           </a:p>
         </p:txBody>
@@ -13821,8 +13400,8 @@
         </p:nvSpPr>
         <p:spPr>
           <a:xfrm>
-            <a:off x="8046720" y="2404872"/>
-            <a:ext cx="3383280" cy="1188720"/>
+            <a:off x="8229600" y="2404872"/>
+            <a:ext cx="3200400" cy="1188720"/>
           </a:xfrm>
           <a:prstGeom prst="rect">
             <a:avLst/>
@@ -13853,7 +13432,7 @@
                 </a:solidFill>
                 <a:latin typeface="Segoe UI"/>
               </a:rPr>
-              <a:t>OpenAI-operated models become enabled by default. They lack HITRUST, SOC 1, and FedRAMP High. Disable them if you need those.</a:t>
+              <a:t>Disable OpenAI-operated models if you require HITRUST, SOC 1, or FedRAMP High.</a:t>
             </a:r>
           </a:p>
         </p:txBody>
@@ -13867,7 +13446,7 @@
         <p:spPr>
           <a:xfrm>
             <a:off x="6858000" y="3730752"/>
-            <a:ext cx="1051560" cy="384048"/>
+            <a:ext cx="1234440" cy="384048"/>
           </a:xfrm>
           <a:prstGeom prst="roundRect">
             <a:avLst>
@@ -13913,7 +13492,7 @@
         <p:spPr>
           <a:xfrm>
             <a:off x="6858000" y="3730752"/>
-            <a:ext cx="1051560" cy="384048"/>
+            <a:ext cx="1234440" cy="384048"/>
           </a:xfrm>
           <a:prstGeom prst="rect">
             <a:avLst/>
@@ -13938,13 +13517,13 @@
               </a:spcAft>
             </a:pPr>
             <a:r>
-              <a:rPr sz="1250" b="1" i="0">
+              <a:rPr sz="1200" b="1" i="0">
                 <a:solidFill>
                   <a:srgbClr val="FFFFFF"/>
                 </a:solidFill>
                 <a:latin typeface="Segoe UI Semibold"/>
               </a:rPr>
-              <a:t>July 31</a:t>
+              <a:t>Weeks 1-4</a:t>
             </a:r>
           </a:p>
         </p:txBody>
@@ -13957,8 +13536,8 @@
         </p:nvSpPr>
         <p:spPr>
           <a:xfrm>
-            <a:off x="8046720" y="3685032"/>
-            <a:ext cx="3383280" cy="1188720"/>
+            <a:off x="8229600" y="3685032"/>
+            <a:ext cx="3200400" cy="1188720"/>
           </a:xfrm>
           <a:prstGeom prst="rect">
             <a:avLst/>
@@ -13989,7 +13568,7 @@
                 </a:solidFill>
                 <a:latin typeface="Segoe UI"/>
               </a:rPr>
-              <a:t>New Restricted SharePoint Search enablement is blocked. Move oversharing control to Restricted Content Discovery.</a:t>
+              <a:t>Move oversharing control to Restricted Content Discovery as legacy search retires.</a:t>
             </a:r>
           </a:p>
         </p:txBody>
@@ -14003,7 +13582,7 @@
         <p:spPr>
           <a:xfrm>
             <a:off x="6858000" y="5010912"/>
-            <a:ext cx="1051560" cy="384048"/>
+            <a:ext cx="1234440" cy="384048"/>
           </a:xfrm>
           <a:prstGeom prst="roundRect">
             <a:avLst>
@@ -14049,7 +13628,7 @@
         <p:spPr>
           <a:xfrm>
             <a:off x="6858000" y="5010912"/>
-            <a:ext cx="1051560" cy="384048"/>
+            <a:ext cx="1234440" cy="384048"/>
           </a:xfrm>
           <a:prstGeom prst="rect">
             <a:avLst/>
@@ -14074,7 +13653,7 @@
               </a:spcAft>
             </a:pPr>
             <a:r>
-              <a:rPr sz="1250" b="1" i="0">
+              <a:rPr sz="1200" b="1" i="0">
                 <a:solidFill>
                   <a:srgbClr val="FFFFFF"/>
                 </a:solidFill>
@@ -14093,8 +13672,8 @@
         </p:nvSpPr>
         <p:spPr>
           <a:xfrm>
-            <a:off x="8046720" y="4965192"/>
-            <a:ext cx="3383280" cy="1188720"/>
+            <a:off x="8229600" y="4965192"/>
+            <a:ext cx="3200400" cy="1188720"/>
           </a:xfrm>
           <a:prstGeom prst="rect">
             <a:avLst/>
@@ -14125,7 +13704,7 @@
                 </a:solidFill>
                 <a:latin typeface="Segoe UI"/>
               </a:rPr>
-              <a:t>Anthropic (powers Cowork and Researcher) sits outside the EU Data Boundary. Confirm BAA coverage before PHI-adjacent use.</a:t>
+              <a:t>Confirm Anthropic / EU Data Boundary BAA coverage before PHI-adjacent Cowork or Researcher use.</a:t>
             </a:r>
           </a:p>
         </p:txBody>
@@ -14393,7 +13972,6 @@
           <a:ln>
             <a:noFill/>
           </a:ln>
-          <a:effectLst/>
           <a:effectLst>
             <a:outerShdw blurRad="90000" dist="38000" dir="5400000" rotWithShape="0">
               <a:srgbClr val="000000">
@@ -14691,7 +14269,6 @@
           <a:ln>
             <a:noFill/>
           </a:ln>
-          <a:effectLst/>
           <a:effectLst>
             <a:outerShdw blurRad="90000" dist="38000" dir="5400000" rotWithShape="0">
               <a:srgbClr val="000000">
@@ -14989,7 +14566,6 @@
           <a:ln>
             <a:noFill/>
           </a:ln>
-          <a:effectLst/>
           <a:effectLst>
             <a:outerShdw blurRad="90000" dist="38000" dir="5400000" rotWithShape="0">
               <a:srgbClr val="000000">

</xml_diff>

<commit_message>
Reframe compliance certification language from provider deficiency to governance choice
Rework the HITRUST / SOC 1 / FedRAMP wording across the guide, one-pager, and deck.
Instead of 'OpenAI-operated models do not carry X, disable them,' frame it as a
provider-selection decision: certification coverage varies by provider, so confirm
which meet your bar and set model-provider access to match (Azure OpenAI retains
coverage). Soften the web-search line to 'manage public web access,' and dial the
callout from red alarm to an amber review. Same substance, calmer and more durable.

Co-authored-by: Copilot <223556219+Copilot@users.noreply.github.com>
</commit_message>
<xml_diff>
--- a/education playground/assets/copilot licensing and deployment/Copilot-Licensing-Exec-Deck.pptx
+++ b/education playground/assets/copilot licensing and deployment/Copilot-Licensing-Exec-Deck.pptx
@@ -7136,7 +7136,7 @@
                 </a:solidFill>
                 <a:latin typeface="Segoe UI"/>
               </a:rPr>
-              <a:t>Disable OpenAI-operated models if you require HITRUST, SOC 1, or FedRAMP High.</a:t>
+              <a:t>Confirm which AI model providers meet your certification bar (HITRUST, SOC 1, FedRAMP High) and set model access to match.</a:t>
             </a:r>
           </a:p>
         </p:txBody>
@@ -9641,7 +9641,7 @@
                 </a:solidFill>
                 <a:latin typeface="Segoe UI"/>
               </a:rPr>
-              <a:t>The OpenAI subprocessor decision first.</a:t>
+              <a:t>The model-provider settings first.</a:t>
             </a:r>
           </a:p>
         </p:txBody>

</xml_diff>

<commit_message>
Apply reviewer feedback across all assets: broaden tiering, Cowork use case, spell out DSPM, clarify frontline + security roles
- Big Picture: frame leaders/managers/analysts as the first paid tier, then
  graduate knowledge workers as usage justifies; link to the role matrix.
- Cowork: add a plain 'what it's for' (manual multi-step work) before billing.
- Spell out DSPM as Data Security Posture Management on first use (guide + deck).
- Frontline: clarify their leaders (e.g. nursing managers) get paid seats.
- Security/Compliance: add a paid seat for their own collaboration alongside
  Security Copilot. Updated the role panels, the at-a-glance matrix, the deck
  matrix, and the one-pager. Compliance certification reframe carried through.

Co-authored-by: Copilot <223556219+Copilot@users.noreply.github.com>
</commit_message>
<xml_diff>
--- a/education playground/assets/copilot licensing and deployment/Copilot-Licensing-Exec-Deck.pptx
+++ b/education playground/assets/copilot licensing and deployment/Copilot-Licensing-Exec-Deck.pptx
@@ -13441,7 +13441,7 @@
                 </a:solidFill>
                 <a:latin typeface="Segoe UI"/>
               </a:rPr>
-              <a:t>Free Chat if eligible</a:t>
+              <a:t>Free Chat; paid seat for leaders</a:t>
             </a:r>
           </a:p>
         </p:txBody>
@@ -13486,7 +13486,7 @@
                 </a:solidFill>
                 <a:latin typeface="Segoe UI"/>
               </a:rPr>
-              <a:t>Web chat on eligible plans</a:t>
+              <a:t>Web chat; recaps for frontline managers</a:t>
             </a:r>
           </a:p>
         </p:txBody>
@@ -13665,7 +13665,7 @@
                 </a:solidFill>
                 <a:latin typeface="Segoe UI"/>
               </a:rPr>
-              <a:t>Security Copilot</a:t>
+              <a:t>Security Copilot + paid seat</a:t>
             </a:r>
           </a:p>
         </p:txBody>
@@ -13710,7 +13710,7 @@
                 </a:solidFill>
                 <a:latin typeface="Segoe UI"/>
               </a:rPr>
-              <a:t>SOC workflows, governance tooling</a:t>
+              <a:t>SOC workflows, governance, own collab</a:t>
             </a:r>
           </a:p>
         </p:txBody>
@@ -16308,7 +16308,7 @@
                 </a:solidFill>
                 <a:latin typeface="Segoe UI"/>
               </a:rPr>
-              <a:t>Your data governance layer: sensitivity labels Copilot honors, DSPM for AI, plus audit, eDiscovery, and insider-risk coverage across prompts and responses.</a:t>
+              <a:t>Your data governance layer: sensitivity labels Copilot honors, Data Security Posture Management (DSPM) for AI, plus audit, eDiscovery, and insider-risk coverage.</a:t>
             </a:r>
           </a:p>
         </p:txBody>

</xml_diff>

<commit_message>
Add second-wave persona coverage (HR, finance, nursing leadership, etc.) and clarify 'per agent interaction'
Reviewer follow-ups. Give the named second-tier functions a concrete home:
a 'second wave of paid seats' callout in the knowledge-worker role (HR,
finance & revenue cycle, marketing & comms, nursing leadership, legal/risk/
compliance, IT & informatics, supply chain, quality & patient safety,
population health), a matching two-wave note under the matrix, and a new deck
slide 'Who gets paid seats next.' Also clarify billing throughout: Free-Chat
users pay per *agent* interaction, and regular Chat stays free (guide, deck,
and one-pager).

Co-authored-by: Copilot <223556219+Copilot@users.noreply.github.com>
</commit_message>
<xml_diff>
--- a/education playground/assets/copilot licensing and deployment/Copilot-Licensing-Exec-Deck.pptx
+++ b/education playground/assets/copilot licensing and deployment/Copilot-Licensing-Exec-Deck.pptx
@@ -9,6 +9,7 @@
     <p:sldId id="257" r:id="rId8"/>
     <p:sldId id="258" r:id="rId9"/>
     <p:sldId id="259" r:id="rId10"/>
+    <p:sldId id="271" r:id="rId22"/>
     <p:sldId id="260" r:id="rId11"/>
     <p:sldId id="261" r:id="rId12"/>
     <p:sldId id="262" r:id="rId13"/>
@@ -3746,7 +3747,7 @@
                 </a:solidFill>
                 <a:latin typeface="Segoe UI"/>
               </a:rPr>
-              <a:t>Free-Chat users pay per interaction.</a:t>
+              <a:t>Free-Chat users pay per agent interaction.</a:t>
             </a:r>
           </a:p>
         </p:txBody>
@@ -9980,6 +9981,1984 @@
                 <a:latin typeface="Segoe UI"/>
               </a:rPr>
               <a:t>heyitsgoad.github.io/copilot-playground</a:t>
+            </a:r>
+          </a:p>
+        </p:txBody>
+      </p:sp>
+    </p:spTree>
+  </p:cSld>
+  <p:clrMapOvr>
+    <a:masterClrMapping/>
+  </p:clrMapOvr>
+</p:sld>
+</file>
+
+<file path=ppt/slides/slide16.xml><?xml version="1.0" encoding="utf-8"?>
+<p:sld xmlns:a="http://schemas.openxmlformats.org/drawingml/2006/main" xmlns:p="http://schemas.openxmlformats.org/presentationml/2006/main" xmlns:r="http://schemas.openxmlformats.org/officeDocument/2006/relationships">
+  <p:cSld>
+    <p:spTree>
+      <p:nvGrpSpPr>
+        <p:cNvPr id="1" name=""/>
+        <p:cNvGrpSpPr/>
+        <p:nvPr/>
+      </p:nvGrpSpPr>
+      <p:grpSpPr/>
+      <p:sp>
+        <p:nvSpPr>
+          <p:cNvPr id="2" name="Rectangle 1"/>
+          <p:cNvSpPr/>
+          <p:nvPr/>
+        </p:nvSpPr>
+        <p:spPr>
+          <a:xfrm>
+            <a:off x="0" y="0"/>
+            <a:ext cx="12191695" cy="6858000"/>
+          </a:xfrm>
+          <a:prstGeom prst="rect">
+            <a:avLst/>
+          </a:prstGeom>
+          <a:solidFill>
+            <a:srgbClr val="F7F4EF"/>
+          </a:solidFill>
+          <a:ln>
+            <a:noFill/>
+          </a:ln>
+          <a:effectLst/>
+        </p:spPr>
+        <p:style>
+          <a:lnRef idx="1">
+            <a:schemeClr val="accent1"/>
+          </a:lnRef>
+          <a:fillRef idx="3">
+            <a:schemeClr val="accent1"/>
+          </a:fillRef>
+          <a:effectRef idx="2">
+            <a:schemeClr val="accent1"/>
+          </a:effectRef>
+          <a:fontRef idx="minor">
+            <a:schemeClr val="lt1"/>
+          </a:fontRef>
+        </p:style>
+        <p:txBody>
+          <a:bodyPr rtlCol="0" anchor="ctr"/>
+          <a:lstStyle/>
+          <a:p>
+            <a:pPr algn="ctr"/>
+          </a:p>
+        </p:txBody>
+      </p:sp>
+      <p:sp>
+        <p:nvSpPr>
+          <p:cNvPr id="3" name="Rectangle 2"/>
+          <p:cNvSpPr/>
+          <p:nvPr/>
+        </p:nvSpPr>
+        <p:spPr>
+          <a:xfrm>
+            <a:off x="640080" y="566928"/>
+            <a:ext cx="384048" cy="82296"/>
+          </a:xfrm>
+          <a:prstGeom prst="rect">
+            <a:avLst/>
+          </a:prstGeom>
+          <a:solidFill>
+            <a:srgbClr val="B11F4B"/>
+          </a:solidFill>
+          <a:ln>
+            <a:noFill/>
+          </a:ln>
+          <a:effectLst/>
+        </p:spPr>
+        <p:style>
+          <a:lnRef idx="1">
+            <a:schemeClr val="accent1"/>
+          </a:lnRef>
+          <a:fillRef idx="3">
+            <a:schemeClr val="accent1"/>
+          </a:fillRef>
+          <a:effectRef idx="2">
+            <a:schemeClr val="accent1"/>
+          </a:effectRef>
+          <a:fontRef idx="minor">
+            <a:schemeClr val="lt1"/>
+          </a:fontRef>
+        </p:style>
+        <p:txBody>
+          <a:bodyPr rtlCol="0" anchor="ctr"/>
+          <a:lstStyle/>
+          <a:p>
+            <a:pPr algn="ctr"/>
+          </a:p>
+        </p:txBody>
+      </p:sp>
+      <p:sp>
+        <p:nvSpPr>
+          <p:cNvPr id="4" name="TextBox 3"/>
+          <p:cNvSpPr txBox="1"/>
+          <p:nvPr/>
+        </p:nvSpPr>
+        <p:spPr>
+          <a:xfrm>
+            <a:off x="1097280" y="457200"/>
+            <a:ext cx="10424160" cy="365760"/>
+          </a:xfrm>
+          <a:prstGeom prst="rect">
+            <a:avLst/>
+          </a:prstGeom>
+          <a:noFill/>
+        </p:spPr>
+        <p:txBody>
+          <a:bodyPr wrap="square" anchor="t" lIns="0" rIns="0" tIns="0" bIns="0">
+            <a:spAutoFit/>
+          </a:bodyPr>
+          <a:lstStyle/>
+          <a:p>
+            <a:pPr algn="l">
+              <a:lnSpc>
+                <a:spcPct val="100000"/>
+              </a:lnSpc>
+              <a:spcBef>
+                <a:spcPts val="0"/>
+              </a:spcBef>
+              <a:spcAft>
+                <a:spcPts val="400"/>
+              </a:spcAft>
+            </a:pPr>
+            <a:r>
+              <a:rPr sz="1250" b="1" i="0" spc="220">
+                <a:solidFill>
+                  <a:srgbClr val="B11F4B"/>
+                </a:solidFill>
+                <a:latin typeface="Segoe UI Semibold"/>
+              </a:rPr>
+              <a:t>THE CENTERPIECE, CONTINUED</a:t>
+            </a:r>
+          </a:p>
+        </p:txBody>
+      </p:sp>
+      <p:sp>
+        <p:nvSpPr>
+          <p:cNvPr id="5" name="TextBox 4"/>
+          <p:cNvSpPr txBox="1"/>
+          <p:nvPr/>
+        </p:nvSpPr>
+        <p:spPr>
+          <a:xfrm>
+            <a:off x="640080" y="841248"/>
+            <a:ext cx="10881360" cy="640080"/>
+          </a:xfrm>
+          <a:prstGeom prst="rect">
+            <a:avLst/>
+          </a:prstGeom>
+          <a:noFill/>
+        </p:spPr>
+        <p:txBody>
+          <a:bodyPr wrap="square" anchor="t" lIns="0" rIns="0" tIns="0" bIns="0">
+            <a:spAutoFit/>
+          </a:bodyPr>
+          <a:lstStyle/>
+          <a:p>
+            <a:pPr algn="l">
+              <a:lnSpc>
+                <a:spcPct val="100000"/>
+              </a:lnSpc>
+              <a:spcBef>
+                <a:spcPts val="0"/>
+              </a:spcBef>
+              <a:spcAft>
+                <a:spcPts val="400"/>
+              </a:spcAft>
+            </a:pPr>
+            <a:r>
+              <a:rPr sz="3300" b="1" i="0">
+                <a:solidFill>
+                  <a:srgbClr val="242424"/>
+                </a:solidFill>
+                <a:latin typeface="Segoe UI Semibold"/>
+              </a:rPr>
+              <a:t>Who gets paid seats next.</a:t>
+            </a:r>
+          </a:p>
+        </p:txBody>
+      </p:sp>
+      <p:sp>
+        <p:nvSpPr>
+          <p:cNvPr id="6" name="TextBox 5"/>
+          <p:cNvSpPr txBox="1"/>
+          <p:nvPr/>
+        </p:nvSpPr>
+        <p:spPr>
+          <a:xfrm>
+            <a:off x="640080" y="1572768"/>
+            <a:ext cx="10972800" cy="457200"/>
+          </a:xfrm>
+          <a:prstGeom prst="rect">
+            <a:avLst/>
+          </a:prstGeom>
+          <a:noFill/>
+        </p:spPr>
+        <p:txBody>
+          <a:bodyPr wrap="square" anchor="t" lIns="0" rIns="0" tIns="0" bIns="0">
+            <a:spAutoFit/>
+          </a:bodyPr>
+          <a:lstStyle/>
+          <a:p>
+            <a:pPr algn="l">
+              <a:lnSpc>
+                <a:spcPct val="115000"/>
+              </a:lnSpc>
+              <a:spcBef>
+                <a:spcPts val="0"/>
+              </a:spcBef>
+              <a:spcAft>
+                <a:spcPts val="400"/>
+              </a:spcAft>
+            </a:pPr>
+            <a:r>
+              <a:rPr sz="1300" b="0" i="0">
+                <a:solidFill>
+                  <a:srgbClr val="5C5C5C"/>
+                </a:solidFill>
+                <a:latin typeface="Segoe UI"/>
+              </a:rPr>
+              <a:t>After the first tier (leaders, managers, analysts), these functions are where paid seats usually pay off next. Graduate them as the dashboard shows real, repeated use, not all at once.</a:t>
+            </a:r>
+          </a:p>
+        </p:txBody>
+      </p:sp>
+      <p:sp>
+        <p:nvSpPr>
+          <p:cNvPr id="7" name="Rounded Rectangle 6"/>
+          <p:cNvSpPr/>
+          <p:nvPr/>
+        </p:nvSpPr>
+        <p:spPr>
+          <a:xfrm>
+            <a:off x="640080" y="2240280"/>
+            <a:ext cx="3584448" cy="1170432"/>
+          </a:xfrm>
+          <a:prstGeom prst="roundRect">
+            <a:avLst>
+              <a:gd name="adj" fmla="val 6000"/>
+            </a:avLst>
+          </a:prstGeom>
+          <a:solidFill>
+            <a:srgbClr val="FFFFFF"/>
+          </a:solidFill>
+          <a:ln w="12700">
+            <a:solidFill>
+              <a:srgbClr val="DEDEDE"/>
+            </a:solidFill>
+          </a:ln>
+          <a:effectLst>
+            <a:outerShdw blurRad="90000" dist="38000" dir="5400000" rotWithShape="0">
+              <a:srgbClr val="000000">
+                <a:alpha val="13000"/>
+              </a:srgbClr>
+            </a:outerShdw>
+          </a:effectLst>
+        </p:spPr>
+        <p:style>
+          <a:lnRef idx="1">
+            <a:schemeClr val="accent1"/>
+          </a:lnRef>
+          <a:fillRef idx="3">
+            <a:schemeClr val="accent1"/>
+          </a:fillRef>
+          <a:effectRef idx="2">
+            <a:schemeClr val="accent1"/>
+          </a:effectRef>
+          <a:fontRef idx="minor">
+            <a:schemeClr val="lt1"/>
+          </a:fontRef>
+        </p:style>
+        <p:txBody>
+          <a:bodyPr rtlCol="0" anchor="ctr"/>
+          <a:lstStyle/>
+          <a:p>
+            <a:pPr algn="ctr"/>
+          </a:p>
+        </p:txBody>
+      </p:sp>
+      <p:sp>
+        <p:nvSpPr>
+          <p:cNvPr id="8" name="Rectangle 7"/>
+          <p:cNvSpPr/>
+          <p:nvPr/>
+        </p:nvSpPr>
+        <p:spPr>
+          <a:xfrm>
+            <a:off x="914400" y="2478024"/>
+            <a:ext cx="384048" cy="73152"/>
+          </a:xfrm>
+          <a:prstGeom prst="rect">
+            <a:avLst/>
+          </a:prstGeom>
+          <a:solidFill>
+            <a:srgbClr val="B11F4B"/>
+          </a:solidFill>
+          <a:ln>
+            <a:noFill/>
+          </a:ln>
+          <a:effectLst/>
+        </p:spPr>
+        <p:style>
+          <a:lnRef idx="1">
+            <a:schemeClr val="accent1"/>
+          </a:lnRef>
+          <a:fillRef idx="3">
+            <a:schemeClr val="accent1"/>
+          </a:fillRef>
+          <a:effectRef idx="2">
+            <a:schemeClr val="accent1"/>
+          </a:effectRef>
+          <a:fontRef idx="minor">
+            <a:schemeClr val="lt1"/>
+          </a:fontRef>
+        </p:style>
+        <p:txBody>
+          <a:bodyPr rtlCol="0" anchor="ctr"/>
+          <a:lstStyle/>
+          <a:p>
+            <a:pPr algn="ctr"/>
+          </a:p>
+        </p:txBody>
+      </p:sp>
+      <p:sp>
+        <p:nvSpPr>
+          <p:cNvPr id="9" name="TextBox 8"/>
+          <p:cNvSpPr txBox="1"/>
+          <p:nvPr/>
+        </p:nvSpPr>
+        <p:spPr>
+          <a:xfrm>
+            <a:off x="914400" y="2624328"/>
+            <a:ext cx="3035808" cy="320040"/>
+          </a:xfrm>
+          <a:prstGeom prst="rect">
+            <a:avLst/>
+          </a:prstGeom>
+          <a:noFill/>
+        </p:spPr>
+        <p:txBody>
+          <a:bodyPr wrap="square" anchor="t" lIns="0" rIns="0" tIns="0" bIns="0">
+            <a:spAutoFit/>
+          </a:bodyPr>
+          <a:lstStyle/>
+          <a:p>
+            <a:pPr algn="l">
+              <a:lnSpc>
+                <a:spcPct val="100000"/>
+              </a:lnSpc>
+              <a:spcBef>
+                <a:spcPts val="0"/>
+              </a:spcBef>
+              <a:spcAft>
+                <a:spcPts val="400"/>
+              </a:spcAft>
+            </a:pPr>
+            <a:r>
+              <a:rPr sz="1350" b="1" i="0">
+                <a:solidFill>
+                  <a:srgbClr val="242424"/>
+                </a:solidFill>
+                <a:latin typeface="Segoe UI Semibold"/>
+              </a:rPr>
+              <a:t>HR</a:t>
+            </a:r>
+          </a:p>
+        </p:txBody>
+      </p:sp>
+      <p:sp>
+        <p:nvSpPr>
+          <p:cNvPr id="10" name="TextBox 9"/>
+          <p:cNvSpPr txBox="1"/>
+          <p:nvPr/>
+        </p:nvSpPr>
+        <p:spPr>
+          <a:xfrm>
+            <a:off x="914400" y="2926080"/>
+            <a:ext cx="3035808" cy="411480"/>
+          </a:xfrm>
+          <a:prstGeom prst="rect">
+            <a:avLst/>
+          </a:prstGeom>
+          <a:noFill/>
+        </p:spPr>
+        <p:txBody>
+          <a:bodyPr wrap="square" anchor="t" lIns="0" rIns="0" tIns="0" bIns="0">
+            <a:spAutoFit/>
+          </a:bodyPr>
+          <a:lstStyle/>
+          <a:p>
+            <a:pPr algn="l">
+              <a:lnSpc>
+                <a:spcPct val="108000"/>
+              </a:lnSpc>
+              <a:spcBef>
+                <a:spcPts val="0"/>
+              </a:spcBef>
+              <a:spcAft>
+                <a:spcPts val="400"/>
+              </a:spcAft>
+            </a:pPr>
+            <a:r>
+              <a:rPr sz="1050" b="0" i="0">
+                <a:solidFill>
+                  <a:srgbClr val="5C5C5C"/>
+                </a:solidFill>
+                <a:latin typeface="Segoe UI"/>
+              </a:rPr>
+              <a:t>Policy drafting, employee-question triage, onboarding content</a:t>
+            </a:r>
+          </a:p>
+        </p:txBody>
+      </p:sp>
+      <p:sp>
+        <p:nvSpPr>
+          <p:cNvPr id="11" name="Rounded Rectangle 10"/>
+          <p:cNvSpPr/>
+          <p:nvPr/>
+        </p:nvSpPr>
+        <p:spPr>
+          <a:xfrm>
+            <a:off x="4347972" y="2240280"/>
+            <a:ext cx="3584448" cy="1170432"/>
+          </a:xfrm>
+          <a:prstGeom prst="roundRect">
+            <a:avLst>
+              <a:gd name="adj" fmla="val 6000"/>
+            </a:avLst>
+          </a:prstGeom>
+          <a:solidFill>
+            <a:srgbClr val="FFFFFF"/>
+          </a:solidFill>
+          <a:ln w="12700">
+            <a:solidFill>
+              <a:srgbClr val="DEDEDE"/>
+            </a:solidFill>
+          </a:ln>
+          <a:effectLst>
+            <a:outerShdw blurRad="90000" dist="38000" dir="5400000" rotWithShape="0">
+              <a:srgbClr val="000000">
+                <a:alpha val="13000"/>
+              </a:srgbClr>
+            </a:outerShdw>
+          </a:effectLst>
+        </p:spPr>
+        <p:style>
+          <a:lnRef idx="1">
+            <a:schemeClr val="accent1"/>
+          </a:lnRef>
+          <a:fillRef idx="3">
+            <a:schemeClr val="accent1"/>
+          </a:fillRef>
+          <a:effectRef idx="2">
+            <a:schemeClr val="accent1"/>
+          </a:effectRef>
+          <a:fontRef idx="minor">
+            <a:schemeClr val="lt1"/>
+          </a:fontRef>
+        </p:style>
+        <p:txBody>
+          <a:bodyPr rtlCol="0" anchor="ctr"/>
+          <a:lstStyle/>
+          <a:p>
+            <a:pPr algn="ctr"/>
+          </a:p>
+        </p:txBody>
+      </p:sp>
+      <p:sp>
+        <p:nvSpPr>
+          <p:cNvPr id="12" name="Rectangle 11"/>
+          <p:cNvSpPr/>
+          <p:nvPr/>
+        </p:nvSpPr>
+        <p:spPr>
+          <a:xfrm>
+            <a:off x="4622292" y="2478024"/>
+            <a:ext cx="384048" cy="73152"/>
+          </a:xfrm>
+          <a:prstGeom prst="rect">
+            <a:avLst/>
+          </a:prstGeom>
+          <a:solidFill>
+            <a:srgbClr val="B11F4B"/>
+          </a:solidFill>
+          <a:ln>
+            <a:noFill/>
+          </a:ln>
+          <a:effectLst/>
+        </p:spPr>
+        <p:style>
+          <a:lnRef idx="1">
+            <a:schemeClr val="accent1"/>
+          </a:lnRef>
+          <a:fillRef idx="3">
+            <a:schemeClr val="accent1"/>
+          </a:fillRef>
+          <a:effectRef idx="2">
+            <a:schemeClr val="accent1"/>
+          </a:effectRef>
+          <a:fontRef idx="minor">
+            <a:schemeClr val="lt1"/>
+          </a:fontRef>
+        </p:style>
+        <p:txBody>
+          <a:bodyPr rtlCol="0" anchor="ctr"/>
+          <a:lstStyle/>
+          <a:p>
+            <a:pPr algn="ctr"/>
+          </a:p>
+        </p:txBody>
+      </p:sp>
+      <p:sp>
+        <p:nvSpPr>
+          <p:cNvPr id="13" name="TextBox 12"/>
+          <p:cNvSpPr txBox="1"/>
+          <p:nvPr/>
+        </p:nvSpPr>
+        <p:spPr>
+          <a:xfrm>
+            <a:off x="4622292" y="2624328"/>
+            <a:ext cx="3035808" cy="320040"/>
+          </a:xfrm>
+          <a:prstGeom prst="rect">
+            <a:avLst/>
+          </a:prstGeom>
+          <a:noFill/>
+        </p:spPr>
+        <p:txBody>
+          <a:bodyPr wrap="square" anchor="t" lIns="0" rIns="0" tIns="0" bIns="0">
+            <a:spAutoFit/>
+          </a:bodyPr>
+          <a:lstStyle/>
+          <a:p>
+            <a:pPr algn="l">
+              <a:lnSpc>
+                <a:spcPct val="100000"/>
+              </a:lnSpc>
+              <a:spcBef>
+                <a:spcPts val="0"/>
+              </a:spcBef>
+              <a:spcAft>
+                <a:spcPts val="400"/>
+              </a:spcAft>
+            </a:pPr>
+            <a:r>
+              <a:rPr sz="1350" b="1" i="0">
+                <a:solidFill>
+                  <a:srgbClr val="242424"/>
+                </a:solidFill>
+                <a:latin typeface="Segoe UI Semibold"/>
+              </a:rPr>
+              <a:t>Finance &amp; revenue cycle</a:t>
+            </a:r>
+          </a:p>
+        </p:txBody>
+      </p:sp>
+      <p:sp>
+        <p:nvSpPr>
+          <p:cNvPr id="14" name="TextBox 13"/>
+          <p:cNvSpPr txBox="1"/>
+          <p:nvPr/>
+        </p:nvSpPr>
+        <p:spPr>
+          <a:xfrm>
+            <a:off x="4622292" y="2926080"/>
+            <a:ext cx="3035808" cy="411480"/>
+          </a:xfrm>
+          <a:prstGeom prst="rect">
+            <a:avLst/>
+          </a:prstGeom>
+          <a:noFill/>
+        </p:spPr>
+        <p:txBody>
+          <a:bodyPr wrap="square" anchor="t" lIns="0" rIns="0" tIns="0" bIns="0">
+            <a:spAutoFit/>
+          </a:bodyPr>
+          <a:lstStyle/>
+          <a:p>
+            <a:pPr algn="l">
+              <a:lnSpc>
+                <a:spcPct val="108000"/>
+              </a:lnSpc>
+              <a:spcBef>
+                <a:spcPts val="0"/>
+              </a:spcBef>
+              <a:spcAft>
+                <a:spcPts val="400"/>
+              </a:spcAft>
+            </a:pPr>
+            <a:r>
+              <a:rPr sz="1050" b="0" i="0">
+                <a:solidFill>
+                  <a:srgbClr val="5C5C5C"/>
+                </a:solidFill>
+                <a:latin typeface="Segoe UI"/>
+              </a:rPr>
+              <a:t>Reporting, reconciliation, denial and variance narratives</a:t>
+            </a:r>
+          </a:p>
+        </p:txBody>
+      </p:sp>
+      <p:sp>
+        <p:nvSpPr>
+          <p:cNvPr id="15" name="Rounded Rectangle 14"/>
+          <p:cNvSpPr/>
+          <p:nvPr/>
+        </p:nvSpPr>
+        <p:spPr>
+          <a:xfrm>
+            <a:off x="8055863" y="2240280"/>
+            <a:ext cx="3584448" cy="1170432"/>
+          </a:xfrm>
+          <a:prstGeom prst="roundRect">
+            <a:avLst>
+              <a:gd name="adj" fmla="val 6000"/>
+            </a:avLst>
+          </a:prstGeom>
+          <a:solidFill>
+            <a:srgbClr val="FFFFFF"/>
+          </a:solidFill>
+          <a:ln w="12700">
+            <a:solidFill>
+              <a:srgbClr val="DEDEDE"/>
+            </a:solidFill>
+          </a:ln>
+          <a:effectLst>
+            <a:outerShdw blurRad="90000" dist="38000" dir="5400000" rotWithShape="0">
+              <a:srgbClr val="000000">
+                <a:alpha val="13000"/>
+              </a:srgbClr>
+            </a:outerShdw>
+          </a:effectLst>
+        </p:spPr>
+        <p:style>
+          <a:lnRef idx="1">
+            <a:schemeClr val="accent1"/>
+          </a:lnRef>
+          <a:fillRef idx="3">
+            <a:schemeClr val="accent1"/>
+          </a:fillRef>
+          <a:effectRef idx="2">
+            <a:schemeClr val="accent1"/>
+          </a:effectRef>
+          <a:fontRef idx="minor">
+            <a:schemeClr val="lt1"/>
+          </a:fontRef>
+        </p:style>
+        <p:txBody>
+          <a:bodyPr rtlCol="0" anchor="ctr"/>
+          <a:lstStyle/>
+          <a:p>
+            <a:pPr algn="ctr"/>
+          </a:p>
+        </p:txBody>
+      </p:sp>
+      <p:sp>
+        <p:nvSpPr>
+          <p:cNvPr id="16" name="Rectangle 15"/>
+          <p:cNvSpPr/>
+          <p:nvPr/>
+        </p:nvSpPr>
+        <p:spPr>
+          <a:xfrm>
+            <a:off x="8330183" y="2478024"/>
+            <a:ext cx="384048" cy="73152"/>
+          </a:xfrm>
+          <a:prstGeom prst="rect">
+            <a:avLst/>
+          </a:prstGeom>
+          <a:solidFill>
+            <a:srgbClr val="B11F4B"/>
+          </a:solidFill>
+          <a:ln>
+            <a:noFill/>
+          </a:ln>
+          <a:effectLst/>
+        </p:spPr>
+        <p:style>
+          <a:lnRef idx="1">
+            <a:schemeClr val="accent1"/>
+          </a:lnRef>
+          <a:fillRef idx="3">
+            <a:schemeClr val="accent1"/>
+          </a:fillRef>
+          <a:effectRef idx="2">
+            <a:schemeClr val="accent1"/>
+          </a:effectRef>
+          <a:fontRef idx="minor">
+            <a:schemeClr val="lt1"/>
+          </a:fontRef>
+        </p:style>
+        <p:txBody>
+          <a:bodyPr rtlCol="0" anchor="ctr"/>
+          <a:lstStyle/>
+          <a:p>
+            <a:pPr algn="ctr"/>
+          </a:p>
+        </p:txBody>
+      </p:sp>
+      <p:sp>
+        <p:nvSpPr>
+          <p:cNvPr id="17" name="TextBox 16"/>
+          <p:cNvSpPr txBox="1"/>
+          <p:nvPr/>
+        </p:nvSpPr>
+        <p:spPr>
+          <a:xfrm>
+            <a:off x="8330183" y="2624328"/>
+            <a:ext cx="3035808" cy="320040"/>
+          </a:xfrm>
+          <a:prstGeom prst="rect">
+            <a:avLst/>
+          </a:prstGeom>
+          <a:noFill/>
+        </p:spPr>
+        <p:txBody>
+          <a:bodyPr wrap="square" anchor="t" lIns="0" rIns="0" tIns="0" bIns="0">
+            <a:spAutoFit/>
+          </a:bodyPr>
+          <a:lstStyle/>
+          <a:p>
+            <a:pPr algn="l">
+              <a:lnSpc>
+                <a:spcPct val="100000"/>
+              </a:lnSpc>
+              <a:spcBef>
+                <a:spcPts val="0"/>
+              </a:spcBef>
+              <a:spcAft>
+                <a:spcPts val="400"/>
+              </a:spcAft>
+            </a:pPr>
+            <a:r>
+              <a:rPr sz="1350" b="1" i="0">
+                <a:solidFill>
+                  <a:srgbClr val="242424"/>
+                </a:solidFill>
+                <a:latin typeface="Segoe UI Semibold"/>
+              </a:rPr>
+              <a:t>Marketing &amp; comms</a:t>
+            </a:r>
+          </a:p>
+        </p:txBody>
+      </p:sp>
+      <p:sp>
+        <p:nvSpPr>
+          <p:cNvPr id="18" name="TextBox 17"/>
+          <p:cNvSpPr txBox="1"/>
+          <p:nvPr/>
+        </p:nvSpPr>
+        <p:spPr>
+          <a:xfrm>
+            <a:off x="8330183" y="2926080"/>
+            <a:ext cx="3035808" cy="411480"/>
+          </a:xfrm>
+          <a:prstGeom prst="rect">
+            <a:avLst/>
+          </a:prstGeom>
+          <a:noFill/>
+        </p:spPr>
+        <p:txBody>
+          <a:bodyPr wrap="square" anchor="t" lIns="0" rIns="0" tIns="0" bIns="0">
+            <a:spAutoFit/>
+          </a:bodyPr>
+          <a:lstStyle/>
+          <a:p>
+            <a:pPr algn="l">
+              <a:lnSpc>
+                <a:spcPct val="108000"/>
+              </a:lnSpc>
+              <a:spcBef>
+                <a:spcPts val="0"/>
+              </a:spcBef>
+              <a:spcAft>
+                <a:spcPts val="400"/>
+              </a:spcAft>
+            </a:pPr>
+            <a:r>
+              <a:rPr sz="1050" b="0" i="0">
+                <a:solidFill>
+                  <a:srgbClr val="5C5C5C"/>
+                </a:solidFill>
+                <a:latin typeface="Segoe UI"/>
+              </a:rPr>
+              <a:t>Campaign content, internal comms, first drafts at volume</a:t>
+            </a:r>
+          </a:p>
+        </p:txBody>
+      </p:sp>
+      <p:sp>
+        <p:nvSpPr>
+          <p:cNvPr id="19" name="Rounded Rectangle 18"/>
+          <p:cNvSpPr/>
+          <p:nvPr/>
+        </p:nvSpPr>
+        <p:spPr>
+          <a:xfrm>
+            <a:off x="640080" y="3566160"/>
+            <a:ext cx="3584448" cy="1170432"/>
+          </a:xfrm>
+          <a:prstGeom prst="roundRect">
+            <a:avLst>
+              <a:gd name="adj" fmla="val 6000"/>
+            </a:avLst>
+          </a:prstGeom>
+          <a:solidFill>
+            <a:srgbClr val="FFFFFF"/>
+          </a:solidFill>
+          <a:ln w="12700">
+            <a:solidFill>
+              <a:srgbClr val="DEDEDE"/>
+            </a:solidFill>
+          </a:ln>
+          <a:effectLst>
+            <a:outerShdw blurRad="90000" dist="38000" dir="5400000" rotWithShape="0">
+              <a:srgbClr val="000000">
+                <a:alpha val="13000"/>
+              </a:srgbClr>
+            </a:outerShdw>
+          </a:effectLst>
+        </p:spPr>
+        <p:style>
+          <a:lnRef idx="1">
+            <a:schemeClr val="accent1"/>
+          </a:lnRef>
+          <a:fillRef idx="3">
+            <a:schemeClr val="accent1"/>
+          </a:fillRef>
+          <a:effectRef idx="2">
+            <a:schemeClr val="accent1"/>
+          </a:effectRef>
+          <a:fontRef idx="minor">
+            <a:schemeClr val="lt1"/>
+          </a:fontRef>
+        </p:style>
+        <p:txBody>
+          <a:bodyPr rtlCol="0" anchor="ctr"/>
+          <a:lstStyle/>
+          <a:p>
+            <a:pPr algn="ctr"/>
+          </a:p>
+        </p:txBody>
+      </p:sp>
+      <p:sp>
+        <p:nvSpPr>
+          <p:cNvPr id="20" name="Rectangle 19"/>
+          <p:cNvSpPr/>
+          <p:nvPr/>
+        </p:nvSpPr>
+        <p:spPr>
+          <a:xfrm>
+            <a:off x="914400" y="3803904"/>
+            <a:ext cx="384048" cy="73152"/>
+          </a:xfrm>
+          <a:prstGeom prst="rect">
+            <a:avLst/>
+          </a:prstGeom>
+          <a:solidFill>
+            <a:srgbClr val="B11F4B"/>
+          </a:solidFill>
+          <a:ln>
+            <a:noFill/>
+          </a:ln>
+          <a:effectLst/>
+        </p:spPr>
+        <p:style>
+          <a:lnRef idx="1">
+            <a:schemeClr val="accent1"/>
+          </a:lnRef>
+          <a:fillRef idx="3">
+            <a:schemeClr val="accent1"/>
+          </a:fillRef>
+          <a:effectRef idx="2">
+            <a:schemeClr val="accent1"/>
+          </a:effectRef>
+          <a:fontRef idx="minor">
+            <a:schemeClr val="lt1"/>
+          </a:fontRef>
+        </p:style>
+        <p:txBody>
+          <a:bodyPr rtlCol="0" anchor="ctr"/>
+          <a:lstStyle/>
+          <a:p>
+            <a:pPr algn="ctr"/>
+          </a:p>
+        </p:txBody>
+      </p:sp>
+      <p:sp>
+        <p:nvSpPr>
+          <p:cNvPr id="21" name="TextBox 20"/>
+          <p:cNvSpPr txBox="1"/>
+          <p:nvPr/>
+        </p:nvSpPr>
+        <p:spPr>
+          <a:xfrm>
+            <a:off x="914400" y="3950208"/>
+            <a:ext cx="3035808" cy="320040"/>
+          </a:xfrm>
+          <a:prstGeom prst="rect">
+            <a:avLst/>
+          </a:prstGeom>
+          <a:noFill/>
+        </p:spPr>
+        <p:txBody>
+          <a:bodyPr wrap="square" anchor="t" lIns="0" rIns="0" tIns="0" bIns="0">
+            <a:spAutoFit/>
+          </a:bodyPr>
+          <a:lstStyle/>
+          <a:p>
+            <a:pPr algn="l">
+              <a:lnSpc>
+                <a:spcPct val="100000"/>
+              </a:lnSpc>
+              <a:spcBef>
+                <a:spcPts val="0"/>
+              </a:spcBef>
+              <a:spcAft>
+                <a:spcPts val="400"/>
+              </a:spcAft>
+            </a:pPr>
+            <a:r>
+              <a:rPr sz="1350" b="1" i="0">
+                <a:solidFill>
+                  <a:srgbClr val="242424"/>
+                </a:solidFill>
+                <a:latin typeface="Segoe UI Semibold"/>
+              </a:rPr>
+              <a:t>Nursing leadership</a:t>
+            </a:r>
+          </a:p>
+        </p:txBody>
+      </p:sp>
+      <p:sp>
+        <p:nvSpPr>
+          <p:cNvPr id="22" name="TextBox 21"/>
+          <p:cNvSpPr txBox="1"/>
+          <p:nvPr/>
+        </p:nvSpPr>
+        <p:spPr>
+          <a:xfrm>
+            <a:off x="914400" y="4251960"/>
+            <a:ext cx="3035808" cy="411480"/>
+          </a:xfrm>
+          <a:prstGeom prst="rect">
+            <a:avLst/>
+          </a:prstGeom>
+          <a:noFill/>
+        </p:spPr>
+        <p:txBody>
+          <a:bodyPr wrap="square" anchor="t" lIns="0" rIns="0" tIns="0" bIns="0">
+            <a:spAutoFit/>
+          </a:bodyPr>
+          <a:lstStyle/>
+          <a:p>
+            <a:pPr algn="l">
+              <a:lnSpc>
+                <a:spcPct val="108000"/>
+              </a:lnSpc>
+              <a:spcBef>
+                <a:spcPts val="0"/>
+              </a:spcBef>
+              <a:spcAft>
+                <a:spcPts val="400"/>
+              </a:spcAft>
+            </a:pPr>
+            <a:r>
+              <a:rPr sz="1050" b="0" i="0">
+                <a:solidFill>
+                  <a:srgbClr val="5C5C5C"/>
+                </a:solidFill>
+                <a:latin typeface="Segoe UI"/>
+              </a:rPr>
+              <a:t>Care-coordination summaries, staffing and committee prep</a:t>
+            </a:r>
+          </a:p>
+        </p:txBody>
+      </p:sp>
+      <p:sp>
+        <p:nvSpPr>
+          <p:cNvPr id="23" name="Rounded Rectangle 22"/>
+          <p:cNvSpPr/>
+          <p:nvPr/>
+        </p:nvSpPr>
+        <p:spPr>
+          <a:xfrm>
+            <a:off x="4347972" y="3566160"/>
+            <a:ext cx="3584448" cy="1170432"/>
+          </a:xfrm>
+          <a:prstGeom prst="roundRect">
+            <a:avLst>
+              <a:gd name="adj" fmla="val 6000"/>
+            </a:avLst>
+          </a:prstGeom>
+          <a:solidFill>
+            <a:srgbClr val="FFFFFF"/>
+          </a:solidFill>
+          <a:ln w="12700">
+            <a:solidFill>
+              <a:srgbClr val="DEDEDE"/>
+            </a:solidFill>
+          </a:ln>
+          <a:effectLst>
+            <a:outerShdw blurRad="90000" dist="38000" dir="5400000" rotWithShape="0">
+              <a:srgbClr val="000000">
+                <a:alpha val="13000"/>
+              </a:srgbClr>
+            </a:outerShdw>
+          </a:effectLst>
+        </p:spPr>
+        <p:style>
+          <a:lnRef idx="1">
+            <a:schemeClr val="accent1"/>
+          </a:lnRef>
+          <a:fillRef idx="3">
+            <a:schemeClr val="accent1"/>
+          </a:fillRef>
+          <a:effectRef idx="2">
+            <a:schemeClr val="accent1"/>
+          </a:effectRef>
+          <a:fontRef idx="minor">
+            <a:schemeClr val="lt1"/>
+          </a:fontRef>
+        </p:style>
+        <p:txBody>
+          <a:bodyPr rtlCol="0" anchor="ctr"/>
+          <a:lstStyle/>
+          <a:p>
+            <a:pPr algn="ctr"/>
+          </a:p>
+        </p:txBody>
+      </p:sp>
+      <p:sp>
+        <p:nvSpPr>
+          <p:cNvPr id="24" name="Rectangle 23"/>
+          <p:cNvSpPr/>
+          <p:nvPr/>
+        </p:nvSpPr>
+        <p:spPr>
+          <a:xfrm>
+            <a:off x="4622292" y="3803904"/>
+            <a:ext cx="384048" cy="73152"/>
+          </a:xfrm>
+          <a:prstGeom prst="rect">
+            <a:avLst/>
+          </a:prstGeom>
+          <a:solidFill>
+            <a:srgbClr val="B11F4B"/>
+          </a:solidFill>
+          <a:ln>
+            <a:noFill/>
+          </a:ln>
+          <a:effectLst/>
+        </p:spPr>
+        <p:style>
+          <a:lnRef idx="1">
+            <a:schemeClr val="accent1"/>
+          </a:lnRef>
+          <a:fillRef idx="3">
+            <a:schemeClr val="accent1"/>
+          </a:fillRef>
+          <a:effectRef idx="2">
+            <a:schemeClr val="accent1"/>
+          </a:effectRef>
+          <a:fontRef idx="minor">
+            <a:schemeClr val="lt1"/>
+          </a:fontRef>
+        </p:style>
+        <p:txBody>
+          <a:bodyPr rtlCol="0" anchor="ctr"/>
+          <a:lstStyle/>
+          <a:p>
+            <a:pPr algn="ctr"/>
+          </a:p>
+        </p:txBody>
+      </p:sp>
+      <p:sp>
+        <p:nvSpPr>
+          <p:cNvPr id="25" name="TextBox 24"/>
+          <p:cNvSpPr txBox="1"/>
+          <p:nvPr/>
+        </p:nvSpPr>
+        <p:spPr>
+          <a:xfrm>
+            <a:off x="4622292" y="3950208"/>
+            <a:ext cx="3035808" cy="320040"/>
+          </a:xfrm>
+          <a:prstGeom prst="rect">
+            <a:avLst/>
+          </a:prstGeom>
+          <a:noFill/>
+        </p:spPr>
+        <p:txBody>
+          <a:bodyPr wrap="square" anchor="t" lIns="0" rIns="0" tIns="0" bIns="0">
+            <a:spAutoFit/>
+          </a:bodyPr>
+          <a:lstStyle/>
+          <a:p>
+            <a:pPr algn="l">
+              <a:lnSpc>
+                <a:spcPct val="100000"/>
+              </a:lnSpc>
+              <a:spcBef>
+                <a:spcPts val="0"/>
+              </a:spcBef>
+              <a:spcAft>
+                <a:spcPts val="400"/>
+              </a:spcAft>
+            </a:pPr>
+            <a:r>
+              <a:rPr sz="1350" b="1" i="0">
+                <a:solidFill>
+                  <a:srgbClr val="242424"/>
+                </a:solidFill>
+                <a:latin typeface="Segoe UI Semibold"/>
+              </a:rPr>
+              <a:t>Legal, risk &amp; compliance</a:t>
+            </a:r>
+          </a:p>
+        </p:txBody>
+      </p:sp>
+      <p:sp>
+        <p:nvSpPr>
+          <p:cNvPr id="26" name="TextBox 25"/>
+          <p:cNvSpPr txBox="1"/>
+          <p:nvPr/>
+        </p:nvSpPr>
+        <p:spPr>
+          <a:xfrm>
+            <a:off x="4622292" y="4251960"/>
+            <a:ext cx="3035808" cy="411480"/>
+          </a:xfrm>
+          <a:prstGeom prst="rect">
+            <a:avLst/>
+          </a:prstGeom>
+          <a:noFill/>
+        </p:spPr>
+        <p:txBody>
+          <a:bodyPr wrap="square" anchor="t" lIns="0" rIns="0" tIns="0" bIns="0">
+            <a:spAutoFit/>
+          </a:bodyPr>
+          <a:lstStyle/>
+          <a:p>
+            <a:pPr algn="l">
+              <a:lnSpc>
+                <a:spcPct val="108000"/>
+              </a:lnSpc>
+              <a:spcBef>
+                <a:spcPts val="0"/>
+              </a:spcBef>
+              <a:spcAft>
+                <a:spcPts val="400"/>
+              </a:spcAft>
+            </a:pPr>
+            <a:r>
+              <a:rPr sz="1050" b="0" i="0">
+                <a:solidFill>
+                  <a:srgbClr val="5C5C5C"/>
+                </a:solidFill>
+                <a:latin typeface="Segoe UI"/>
+              </a:rPr>
+              <a:t>Document review, policy summarization, audit prep</a:t>
+            </a:r>
+          </a:p>
+        </p:txBody>
+      </p:sp>
+      <p:sp>
+        <p:nvSpPr>
+          <p:cNvPr id="27" name="Rounded Rectangle 26"/>
+          <p:cNvSpPr/>
+          <p:nvPr/>
+        </p:nvSpPr>
+        <p:spPr>
+          <a:xfrm>
+            <a:off x="8055863" y="3566160"/>
+            <a:ext cx="3584448" cy="1170432"/>
+          </a:xfrm>
+          <a:prstGeom prst="roundRect">
+            <a:avLst>
+              <a:gd name="adj" fmla="val 6000"/>
+            </a:avLst>
+          </a:prstGeom>
+          <a:solidFill>
+            <a:srgbClr val="FFFFFF"/>
+          </a:solidFill>
+          <a:ln w="12700">
+            <a:solidFill>
+              <a:srgbClr val="DEDEDE"/>
+            </a:solidFill>
+          </a:ln>
+          <a:effectLst>
+            <a:outerShdw blurRad="90000" dist="38000" dir="5400000" rotWithShape="0">
+              <a:srgbClr val="000000">
+                <a:alpha val="13000"/>
+              </a:srgbClr>
+            </a:outerShdw>
+          </a:effectLst>
+        </p:spPr>
+        <p:style>
+          <a:lnRef idx="1">
+            <a:schemeClr val="accent1"/>
+          </a:lnRef>
+          <a:fillRef idx="3">
+            <a:schemeClr val="accent1"/>
+          </a:fillRef>
+          <a:effectRef idx="2">
+            <a:schemeClr val="accent1"/>
+          </a:effectRef>
+          <a:fontRef idx="minor">
+            <a:schemeClr val="lt1"/>
+          </a:fontRef>
+        </p:style>
+        <p:txBody>
+          <a:bodyPr rtlCol="0" anchor="ctr"/>
+          <a:lstStyle/>
+          <a:p>
+            <a:pPr algn="ctr"/>
+          </a:p>
+        </p:txBody>
+      </p:sp>
+      <p:sp>
+        <p:nvSpPr>
+          <p:cNvPr id="28" name="Rectangle 27"/>
+          <p:cNvSpPr/>
+          <p:nvPr/>
+        </p:nvSpPr>
+        <p:spPr>
+          <a:xfrm>
+            <a:off x="8330183" y="3803904"/>
+            <a:ext cx="384048" cy="73152"/>
+          </a:xfrm>
+          <a:prstGeom prst="rect">
+            <a:avLst/>
+          </a:prstGeom>
+          <a:solidFill>
+            <a:srgbClr val="B11F4B"/>
+          </a:solidFill>
+          <a:ln>
+            <a:noFill/>
+          </a:ln>
+          <a:effectLst/>
+        </p:spPr>
+        <p:style>
+          <a:lnRef idx="1">
+            <a:schemeClr val="accent1"/>
+          </a:lnRef>
+          <a:fillRef idx="3">
+            <a:schemeClr val="accent1"/>
+          </a:fillRef>
+          <a:effectRef idx="2">
+            <a:schemeClr val="accent1"/>
+          </a:effectRef>
+          <a:fontRef idx="minor">
+            <a:schemeClr val="lt1"/>
+          </a:fontRef>
+        </p:style>
+        <p:txBody>
+          <a:bodyPr rtlCol="0" anchor="ctr"/>
+          <a:lstStyle/>
+          <a:p>
+            <a:pPr algn="ctr"/>
+          </a:p>
+        </p:txBody>
+      </p:sp>
+      <p:sp>
+        <p:nvSpPr>
+          <p:cNvPr id="29" name="TextBox 28"/>
+          <p:cNvSpPr txBox="1"/>
+          <p:nvPr/>
+        </p:nvSpPr>
+        <p:spPr>
+          <a:xfrm>
+            <a:off x="8330183" y="3950208"/>
+            <a:ext cx="3035808" cy="320040"/>
+          </a:xfrm>
+          <a:prstGeom prst="rect">
+            <a:avLst/>
+          </a:prstGeom>
+          <a:noFill/>
+        </p:spPr>
+        <p:txBody>
+          <a:bodyPr wrap="square" anchor="t" lIns="0" rIns="0" tIns="0" bIns="0">
+            <a:spAutoFit/>
+          </a:bodyPr>
+          <a:lstStyle/>
+          <a:p>
+            <a:pPr algn="l">
+              <a:lnSpc>
+                <a:spcPct val="100000"/>
+              </a:lnSpc>
+              <a:spcBef>
+                <a:spcPts val="0"/>
+              </a:spcBef>
+              <a:spcAft>
+                <a:spcPts val="400"/>
+              </a:spcAft>
+            </a:pPr>
+            <a:r>
+              <a:rPr sz="1350" b="1" i="0">
+                <a:solidFill>
+                  <a:srgbClr val="242424"/>
+                </a:solidFill>
+                <a:latin typeface="Segoe UI Semibold"/>
+              </a:rPr>
+              <a:t>IT &amp; informatics</a:t>
+            </a:r>
+          </a:p>
+        </p:txBody>
+      </p:sp>
+      <p:sp>
+        <p:nvSpPr>
+          <p:cNvPr id="30" name="TextBox 29"/>
+          <p:cNvSpPr txBox="1"/>
+          <p:nvPr/>
+        </p:nvSpPr>
+        <p:spPr>
+          <a:xfrm>
+            <a:off x="8330183" y="4251960"/>
+            <a:ext cx="3035808" cy="411480"/>
+          </a:xfrm>
+          <a:prstGeom prst="rect">
+            <a:avLst/>
+          </a:prstGeom>
+          <a:noFill/>
+        </p:spPr>
+        <p:txBody>
+          <a:bodyPr wrap="square" anchor="t" lIns="0" rIns="0" tIns="0" bIns="0">
+            <a:spAutoFit/>
+          </a:bodyPr>
+          <a:lstStyle/>
+          <a:p>
+            <a:pPr algn="l">
+              <a:lnSpc>
+                <a:spcPct val="108000"/>
+              </a:lnSpc>
+              <a:spcBef>
+                <a:spcPts val="0"/>
+              </a:spcBef>
+              <a:spcAft>
+                <a:spcPts val="400"/>
+              </a:spcAft>
+            </a:pPr>
+            <a:r>
+              <a:rPr sz="1050" b="0" i="0">
+                <a:solidFill>
+                  <a:srgbClr val="5C5C5C"/>
+                </a:solidFill>
+                <a:latin typeface="Segoe UI"/>
+              </a:rPr>
+              <a:t>Ticket triage, documentation, knowledge-base upkeep</a:t>
+            </a:r>
+          </a:p>
+        </p:txBody>
+      </p:sp>
+      <p:sp>
+        <p:nvSpPr>
+          <p:cNvPr id="31" name="Rounded Rectangle 30"/>
+          <p:cNvSpPr/>
+          <p:nvPr/>
+        </p:nvSpPr>
+        <p:spPr>
+          <a:xfrm>
+            <a:off x="640080" y="4892040"/>
+            <a:ext cx="3584448" cy="1170432"/>
+          </a:xfrm>
+          <a:prstGeom prst="roundRect">
+            <a:avLst>
+              <a:gd name="adj" fmla="val 6000"/>
+            </a:avLst>
+          </a:prstGeom>
+          <a:solidFill>
+            <a:srgbClr val="FFFFFF"/>
+          </a:solidFill>
+          <a:ln w="12700">
+            <a:solidFill>
+              <a:srgbClr val="DEDEDE"/>
+            </a:solidFill>
+          </a:ln>
+          <a:effectLst>
+            <a:outerShdw blurRad="90000" dist="38000" dir="5400000" rotWithShape="0">
+              <a:srgbClr val="000000">
+                <a:alpha val="13000"/>
+              </a:srgbClr>
+            </a:outerShdw>
+          </a:effectLst>
+        </p:spPr>
+        <p:style>
+          <a:lnRef idx="1">
+            <a:schemeClr val="accent1"/>
+          </a:lnRef>
+          <a:fillRef idx="3">
+            <a:schemeClr val="accent1"/>
+          </a:fillRef>
+          <a:effectRef idx="2">
+            <a:schemeClr val="accent1"/>
+          </a:effectRef>
+          <a:fontRef idx="minor">
+            <a:schemeClr val="lt1"/>
+          </a:fontRef>
+        </p:style>
+        <p:txBody>
+          <a:bodyPr rtlCol="0" anchor="ctr"/>
+          <a:lstStyle/>
+          <a:p>
+            <a:pPr algn="ctr"/>
+          </a:p>
+        </p:txBody>
+      </p:sp>
+      <p:sp>
+        <p:nvSpPr>
+          <p:cNvPr id="32" name="Rectangle 31"/>
+          <p:cNvSpPr/>
+          <p:nvPr/>
+        </p:nvSpPr>
+        <p:spPr>
+          <a:xfrm>
+            <a:off x="914400" y="5129783"/>
+            <a:ext cx="384048" cy="73152"/>
+          </a:xfrm>
+          <a:prstGeom prst="rect">
+            <a:avLst/>
+          </a:prstGeom>
+          <a:solidFill>
+            <a:srgbClr val="B11F4B"/>
+          </a:solidFill>
+          <a:ln>
+            <a:noFill/>
+          </a:ln>
+          <a:effectLst/>
+        </p:spPr>
+        <p:style>
+          <a:lnRef idx="1">
+            <a:schemeClr val="accent1"/>
+          </a:lnRef>
+          <a:fillRef idx="3">
+            <a:schemeClr val="accent1"/>
+          </a:fillRef>
+          <a:effectRef idx="2">
+            <a:schemeClr val="accent1"/>
+          </a:effectRef>
+          <a:fontRef idx="minor">
+            <a:schemeClr val="lt1"/>
+          </a:fontRef>
+        </p:style>
+        <p:txBody>
+          <a:bodyPr rtlCol="0" anchor="ctr"/>
+          <a:lstStyle/>
+          <a:p>
+            <a:pPr algn="ctr"/>
+          </a:p>
+        </p:txBody>
+      </p:sp>
+      <p:sp>
+        <p:nvSpPr>
+          <p:cNvPr id="33" name="TextBox 32"/>
+          <p:cNvSpPr txBox="1"/>
+          <p:nvPr/>
+        </p:nvSpPr>
+        <p:spPr>
+          <a:xfrm>
+            <a:off x="914400" y="5276088"/>
+            <a:ext cx="3035808" cy="320040"/>
+          </a:xfrm>
+          <a:prstGeom prst="rect">
+            <a:avLst/>
+          </a:prstGeom>
+          <a:noFill/>
+        </p:spPr>
+        <p:txBody>
+          <a:bodyPr wrap="square" anchor="t" lIns="0" rIns="0" tIns="0" bIns="0">
+            <a:spAutoFit/>
+          </a:bodyPr>
+          <a:lstStyle/>
+          <a:p>
+            <a:pPr algn="l">
+              <a:lnSpc>
+                <a:spcPct val="100000"/>
+              </a:lnSpc>
+              <a:spcBef>
+                <a:spcPts val="0"/>
+              </a:spcBef>
+              <a:spcAft>
+                <a:spcPts val="400"/>
+              </a:spcAft>
+            </a:pPr>
+            <a:r>
+              <a:rPr sz="1350" b="1" i="0">
+                <a:solidFill>
+                  <a:srgbClr val="242424"/>
+                </a:solidFill>
+                <a:latin typeface="Segoe UI Semibold"/>
+              </a:rPr>
+              <a:t>Supply chain</a:t>
+            </a:r>
+          </a:p>
+        </p:txBody>
+      </p:sp>
+      <p:sp>
+        <p:nvSpPr>
+          <p:cNvPr id="34" name="TextBox 33"/>
+          <p:cNvSpPr txBox="1"/>
+          <p:nvPr/>
+        </p:nvSpPr>
+        <p:spPr>
+          <a:xfrm>
+            <a:off x="914400" y="5577840"/>
+            <a:ext cx="3035808" cy="411480"/>
+          </a:xfrm>
+          <a:prstGeom prst="rect">
+            <a:avLst/>
+          </a:prstGeom>
+          <a:noFill/>
+        </p:spPr>
+        <p:txBody>
+          <a:bodyPr wrap="square" anchor="t" lIns="0" rIns="0" tIns="0" bIns="0">
+            <a:spAutoFit/>
+          </a:bodyPr>
+          <a:lstStyle/>
+          <a:p>
+            <a:pPr algn="l">
+              <a:lnSpc>
+                <a:spcPct val="108000"/>
+              </a:lnSpc>
+              <a:spcBef>
+                <a:spcPts val="0"/>
+              </a:spcBef>
+              <a:spcAft>
+                <a:spcPts val="400"/>
+              </a:spcAft>
+            </a:pPr>
+            <a:r>
+              <a:rPr sz="1050" b="0" i="0">
+                <a:solidFill>
+                  <a:srgbClr val="5C5C5C"/>
+                </a:solidFill>
+                <a:latin typeface="Segoe UI"/>
+              </a:rPr>
+              <a:t>Vendor and contract summaries, operational reporting</a:t>
+            </a:r>
+          </a:p>
+        </p:txBody>
+      </p:sp>
+      <p:sp>
+        <p:nvSpPr>
+          <p:cNvPr id="35" name="Rounded Rectangle 34"/>
+          <p:cNvSpPr/>
+          <p:nvPr/>
+        </p:nvSpPr>
+        <p:spPr>
+          <a:xfrm>
+            <a:off x="4347972" y="4892040"/>
+            <a:ext cx="3584448" cy="1170432"/>
+          </a:xfrm>
+          <a:prstGeom prst="roundRect">
+            <a:avLst>
+              <a:gd name="adj" fmla="val 6000"/>
+            </a:avLst>
+          </a:prstGeom>
+          <a:solidFill>
+            <a:srgbClr val="FFFFFF"/>
+          </a:solidFill>
+          <a:ln w="12700">
+            <a:solidFill>
+              <a:srgbClr val="DEDEDE"/>
+            </a:solidFill>
+          </a:ln>
+          <a:effectLst>
+            <a:outerShdw blurRad="90000" dist="38000" dir="5400000" rotWithShape="0">
+              <a:srgbClr val="000000">
+                <a:alpha val="13000"/>
+              </a:srgbClr>
+            </a:outerShdw>
+          </a:effectLst>
+        </p:spPr>
+        <p:style>
+          <a:lnRef idx="1">
+            <a:schemeClr val="accent1"/>
+          </a:lnRef>
+          <a:fillRef idx="3">
+            <a:schemeClr val="accent1"/>
+          </a:fillRef>
+          <a:effectRef idx="2">
+            <a:schemeClr val="accent1"/>
+          </a:effectRef>
+          <a:fontRef idx="minor">
+            <a:schemeClr val="lt1"/>
+          </a:fontRef>
+        </p:style>
+        <p:txBody>
+          <a:bodyPr rtlCol="0" anchor="ctr"/>
+          <a:lstStyle/>
+          <a:p>
+            <a:pPr algn="ctr"/>
+          </a:p>
+        </p:txBody>
+      </p:sp>
+      <p:sp>
+        <p:nvSpPr>
+          <p:cNvPr id="36" name="Rectangle 35"/>
+          <p:cNvSpPr/>
+          <p:nvPr/>
+        </p:nvSpPr>
+        <p:spPr>
+          <a:xfrm>
+            <a:off x="4622292" y="5129783"/>
+            <a:ext cx="384048" cy="73152"/>
+          </a:xfrm>
+          <a:prstGeom prst="rect">
+            <a:avLst/>
+          </a:prstGeom>
+          <a:solidFill>
+            <a:srgbClr val="B11F4B"/>
+          </a:solidFill>
+          <a:ln>
+            <a:noFill/>
+          </a:ln>
+          <a:effectLst/>
+        </p:spPr>
+        <p:style>
+          <a:lnRef idx="1">
+            <a:schemeClr val="accent1"/>
+          </a:lnRef>
+          <a:fillRef idx="3">
+            <a:schemeClr val="accent1"/>
+          </a:fillRef>
+          <a:effectRef idx="2">
+            <a:schemeClr val="accent1"/>
+          </a:effectRef>
+          <a:fontRef idx="minor">
+            <a:schemeClr val="lt1"/>
+          </a:fontRef>
+        </p:style>
+        <p:txBody>
+          <a:bodyPr rtlCol="0" anchor="ctr"/>
+          <a:lstStyle/>
+          <a:p>
+            <a:pPr algn="ctr"/>
+          </a:p>
+        </p:txBody>
+      </p:sp>
+      <p:sp>
+        <p:nvSpPr>
+          <p:cNvPr id="37" name="TextBox 36"/>
+          <p:cNvSpPr txBox="1"/>
+          <p:nvPr/>
+        </p:nvSpPr>
+        <p:spPr>
+          <a:xfrm>
+            <a:off x="4622292" y="5276088"/>
+            <a:ext cx="3035808" cy="320040"/>
+          </a:xfrm>
+          <a:prstGeom prst="rect">
+            <a:avLst/>
+          </a:prstGeom>
+          <a:noFill/>
+        </p:spPr>
+        <p:txBody>
+          <a:bodyPr wrap="square" anchor="t" lIns="0" rIns="0" tIns="0" bIns="0">
+            <a:spAutoFit/>
+          </a:bodyPr>
+          <a:lstStyle/>
+          <a:p>
+            <a:pPr algn="l">
+              <a:lnSpc>
+                <a:spcPct val="100000"/>
+              </a:lnSpc>
+              <a:spcBef>
+                <a:spcPts val="0"/>
+              </a:spcBef>
+              <a:spcAft>
+                <a:spcPts val="400"/>
+              </a:spcAft>
+            </a:pPr>
+            <a:r>
+              <a:rPr sz="1350" b="1" i="0">
+                <a:solidFill>
+                  <a:srgbClr val="242424"/>
+                </a:solidFill>
+                <a:latin typeface="Segoe UI Semibold"/>
+              </a:rPr>
+              <a:t>Quality &amp; patient safety</a:t>
+            </a:r>
+          </a:p>
+        </p:txBody>
+      </p:sp>
+      <p:sp>
+        <p:nvSpPr>
+          <p:cNvPr id="38" name="TextBox 37"/>
+          <p:cNvSpPr txBox="1"/>
+          <p:nvPr/>
+        </p:nvSpPr>
+        <p:spPr>
+          <a:xfrm>
+            <a:off x="4622292" y="5577840"/>
+            <a:ext cx="3035808" cy="411480"/>
+          </a:xfrm>
+          <a:prstGeom prst="rect">
+            <a:avLst/>
+          </a:prstGeom>
+          <a:noFill/>
+        </p:spPr>
+        <p:txBody>
+          <a:bodyPr wrap="square" anchor="t" lIns="0" rIns="0" tIns="0" bIns="0">
+            <a:spAutoFit/>
+          </a:bodyPr>
+          <a:lstStyle/>
+          <a:p>
+            <a:pPr algn="l">
+              <a:lnSpc>
+                <a:spcPct val="108000"/>
+              </a:lnSpc>
+              <a:spcBef>
+                <a:spcPts val="0"/>
+              </a:spcBef>
+              <a:spcAft>
+                <a:spcPts val="400"/>
+              </a:spcAft>
+            </a:pPr>
+            <a:r>
+              <a:rPr sz="1050" b="0" i="0">
+                <a:solidFill>
+                  <a:srgbClr val="5C5C5C"/>
+                </a:solidFill>
+                <a:latin typeface="Segoe UI"/>
+              </a:rPr>
+              <a:t>Event summaries, report drafting, trend write-ups</a:t>
+            </a:r>
+          </a:p>
+        </p:txBody>
+      </p:sp>
+      <p:sp>
+        <p:nvSpPr>
+          <p:cNvPr id="39" name="Rounded Rectangle 38"/>
+          <p:cNvSpPr/>
+          <p:nvPr/>
+        </p:nvSpPr>
+        <p:spPr>
+          <a:xfrm>
+            <a:off x="8055863" y="4892040"/>
+            <a:ext cx="3584448" cy="1170432"/>
+          </a:xfrm>
+          <a:prstGeom prst="roundRect">
+            <a:avLst>
+              <a:gd name="adj" fmla="val 6000"/>
+            </a:avLst>
+          </a:prstGeom>
+          <a:solidFill>
+            <a:srgbClr val="FFFFFF"/>
+          </a:solidFill>
+          <a:ln w="12700">
+            <a:solidFill>
+              <a:srgbClr val="DEDEDE"/>
+            </a:solidFill>
+          </a:ln>
+          <a:effectLst>
+            <a:outerShdw blurRad="90000" dist="38000" dir="5400000" rotWithShape="0">
+              <a:srgbClr val="000000">
+                <a:alpha val="13000"/>
+              </a:srgbClr>
+            </a:outerShdw>
+          </a:effectLst>
+        </p:spPr>
+        <p:style>
+          <a:lnRef idx="1">
+            <a:schemeClr val="accent1"/>
+          </a:lnRef>
+          <a:fillRef idx="3">
+            <a:schemeClr val="accent1"/>
+          </a:fillRef>
+          <a:effectRef idx="2">
+            <a:schemeClr val="accent1"/>
+          </a:effectRef>
+          <a:fontRef idx="minor">
+            <a:schemeClr val="lt1"/>
+          </a:fontRef>
+        </p:style>
+        <p:txBody>
+          <a:bodyPr rtlCol="0" anchor="ctr"/>
+          <a:lstStyle/>
+          <a:p>
+            <a:pPr algn="ctr"/>
+          </a:p>
+        </p:txBody>
+      </p:sp>
+      <p:sp>
+        <p:nvSpPr>
+          <p:cNvPr id="40" name="Rectangle 39"/>
+          <p:cNvSpPr/>
+          <p:nvPr/>
+        </p:nvSpPr>
+        <p:spPr>
+          <a:xfrm>
+            <a:off x="8330183" y="5129783"/>
+            <a:ext cx="384048" cy="73152"/>
+          </a:xfrm>
+          <a:prstGeom prst="rect">
+            <a:avLst/>
+          </a:prstGeom>
+          <a:solidFill>
+            <a:srgbClr val="B11F4B"/>
+          </a:solidFill>
+          <a:ln>
+            <a:noFill/>
+          </a:ln>
+          <a:effectLst/>
+        </p:spPr>
+        <p:style>
+          <a:lnRef idx="1">
+            <a:schemeClr val="accent1"/>
+          </a:lnRef>
+          <a:fillRef idx="3">
+            <a:schemeClr val="accent1"/>
+          </a:fillRef>
+          <a:effectRef idx="2">
+            <a:schemeClr val="accent1"/>
+          </a:effectRef>
+          <a:fontRef idx="minor">
+            <a:schemeClr val="lt1"/>
+          </a:fontRef>
+        </p:style>
+        <p:txBody>
+          <a:bodyPr rtlCol="0" anchor="ctr"/>
+          <a:lstStyle/>
+          <a:p>
+            <a:pPr algn="ctr"/>
+          </a:p>
+        </p:txBody>
+      </p:sp>
+      <p:sp>
+        <p:nvSpPr>
+          <p:cNvPr id="41" name="TextBox 40"/>
+          <p:cNvSpPr txBox="1"/>
+          <p:nvPr/>
+        </p:nvSpPr>
+        <p:spPr>
+          <a:xfrm>
+            <a:off x="8330183" y="5276088"/>
+            <a:ext cx="3035808" cy="320040"/>
+          </a:xfrm>
+          <a:prstGeom prst="rect">
+            <a:avLst/>
+          </a:prstGeom>
+          <a:noFill/>
+        </p:spPr>
+        <p:txBody>
+          <a:bodyPr wrap="square" anchor="t" lIns="0" rIns="0" tIns="0" bIns="0">
+            <a:spAutoFit/>
+          </a:bodyPr>
+          <a:lstStyle/>
+          <a:p>
+            <a:pPr algn="l">
+              <a:lnSpc>
+                <a:spcPct val="100000"/>
+              </a:lnSpc>
+              <a:spcBef>
+                <a:spcPts val="0"/>
+              </a:spcBef>
+              <a:spcAft>
+                <a:spcPts val="400"/>
+              </a:spcAft>
+            </a:pPr>
+            <a:r>
+              <a:rPr sz="1350" b="1" i="0">
+                <a:solidFill>
+                  <a:srgbClr val="242424"/>
+                </a:solidFill>
+                <a:latin typeface="Segoe UI Semibold"/>
+              </a:rPr>
+              <a:t>Population health</a:t>
+            </a:r>
+          </a:p>
+        </p:txBody>
+      </p:sp>
+      <p:sp>
+        <p:nvSpPr>
+          <p:cNvPr id="42" name="TextBox 41"/>
+          <p:cNvSpPr txBox="1"/>
+          <p:nvPr/>
+        </p:nvSpPr>
+        <p:spPr>
+          <a:xfrm>
+            <a:off x="8330183" y="5577840"/>
+            <a:ext cx="3035808" cy="411480"/>
+          </a:xfrm>
+          <a:prstGeom prst="rect">
+            <a:avLst/>
+          </a:prstGeom>
+          <a:noFill/>
+        </p:spPr>
+        <p:txBody>
+          <a:bodyPr wrap="square" anchor="t" lIns="0" rIns="0" tIns="0" bIns="0">
+            <a:spAutoFit/>
+          </a:bodyPr>
+          <a:lstStyle/>
+          <a:p>
+            <a:pPr algn="l">
+              <a:lnSpc>
+                <a:spcPct val="108000"/>
+              </a:lnSpc>
+              <a:spcBef>
+                <a:spcPts val="0"/>
+              </a:spcBef>
+              <a:spcAft>
+                <a:spcPts val="400"/>
+              </a:spcAft>
+            </a:pPr>
+            <a:r>
+              <a:rPr sz="1050" b="0" i="0">
+                <a:solidFill>
+                  <a:srgbClr val="5C5C5C"/>
+                </a:solidFill>
+                <a:latin typeface="Segoe UI"/>
+              </a:rPr>
+              <a:t>Multi-source synthesis and program reporting</a:t>
+            </a:r>
+          </a:p>
+        </p:txBody>
+      </p:sp>
+      <p:sp>
+        <p:nvSpPr>
+          <p:cNvPr id="43" name="TextBox 42"/>
+          <p:cNvSpPr txBox="1"/>
+          <p:nvPr/>
+        </p:nvSpPr>
+        <p:spPr>
+          <a:xfrm>
+            <a:off x="640080" y="6263640"/>
+            <a:ext cx="10908792" cy="365760"/>
+          </a:xfrm>
+          <a:prstGeom prst="rect">
+            <a:avLst/>
+          </a:prstGeom>
+          <a:noFill/>
+        </p:spPr>
+        <p:txBody>
+          <a:bodyPr wrap="square" anchor="t" lIns="0" rIns="0" tIns="0" bIns="0">
+            <a:spAutoFit/>
+          </a:bodyPr>
+          <a:lstStyle/>
+          <a:p>
+            <a:pPr algn="l">
+              <a:lnSpc>
+                <a:spcPct val="100000"/>
+              </a:lnSpc>
+              <a:spcBef>
+                <a:spcPts val="0"/>
+              </a:spcBef>
+              <a:spcAft>
+                <a:spcPts val="400"/>
+              </a:spcAft>
+            </a:pPr>
+            <a:r>
+              <a:rPr sz="1150" b="0" i="1">
+                <a:solidFill>
+                  <a:srgbClr val="6F6F6F"/>
+                </a:solidFill>
+                <a:latin typeface="Segoe UI"/>
+              </a:rPr>
+              <a:t>Give free Chat to everyone eligible first. Expand into these with usage data, not requests.</a:t>
             </a:r>
           </a:p>
         </p:txBody>

</xml_diff>